<commit_message>
Change template config for premium template
</commit_message>
<xml_diff>
--- a/make_presentation/templates/templates/premium/no_logo_10.pptx
+++ b/make_presentation/templates/templates/premium/no_logo_10.pptx
@@ -69,95 +69,20 @@
             <a:noAutofit/>
           </a:bodyPr>
           <a:p>
-            <a:pPr algn="ctr">
-              <a:buNone/>
-            </a:pPr>
-            <a:r>
-              <a:rPr b="0" lang="en-US" sz="4400" spc="-1" strike="noStrike">
-                <a:latin typeface="Arial"/>
-              </a:rPr>
-              <a:t>C</a:t>
-            </a:r>
-            <a:r>
-              <a:rPr b="0" lang="en-US" sz="4400" spc="-1" strike="noStrike">
-                <a:latin typeface="Arial"/>
-              </a:rPr>
-              <a:t>li</a:t>
-            </a:r>
-            <a:r>
-              <a:rPr b="0" lang="en-US" sz="4400" spc="-1" strike="noStrike">
-                <a:latin typeface="Arial"/>
-              </a:rPr>
-              <a:t>c</a:t>
-            </a:r>
-            <a:r>
-              <a:rPr b="0" lang="en-US" sz="4400" spc="-1" strike="noStrike">
-                <a:latin typeface="Arial"/>
-              </a:rPr>
-              <a:t>k </a:t>
-            </a:r>
-            <a:r>
-              <a:rPr b="0" lang="en-US" sz="4400" spc="-1" strike="noStrike">
-                <a:latin typeface="Arial"/>
-              </a:rPr>
-              <a:t>to </a:t>
-            </a:r>
-            <a:r>
-              <a:rPr b="0" lang="en-US" sz="4400" spc="-1" strike="noStrike">
-                <a:latin typeface="Arial"/>
-              </a:rPr>
-              <a:t>m</a:t>
-            </a:r>
-            <a:r>
-              <a:rPr b="0" lang="en-US" sz="4400" spc="-1" strike="noStrike">
-                <a:latin typeface="Arial"/>
-              </a:rPr>
-              <a:t>o</a:t>
-            </a:r>
-            <a:r>
-              <a:rPr b="0" lang="en-US" sz="4400" spc="-1" strike="noStrike">
-                <a:latin typeface="Arial"/>
-              </a:rPr>
-              <a:t>v</a:t>
-            </a:r>
-            <a:r>
-              <a:rPr b="0" lang="en-US" sz="4400" spc="-1" strike="noStrike">
-                <a:latin typeface="Arial"/>
-              </a:rPr>
-              <a:t>e </a:t>
-            </a:r>
-            <a:r>
-              <a:rPr b="0" lang="en-US" sz="4400" spc="-1" strike="noStrike">
-                <a:latin typeface="Arial"/>
-              </a:rPr>
-              <a:t>th</a:t>
-            </a:r>
-            <a:r>
-              <a:rPr b="0" lang="en-US" sz="4400" spc="-1" strike="noStrike">
-                <a:latin typeface="Arial"/>
-              </a:rPr>
-              <a:t>e </a:t>
-            </a:r>
-            <a:r>
-              <a:rPr b="0" lang="en-US" sz="4400" spc="-1" strike="noStrike">
-                <a:latin typeface="Arial"/>
-              </a:rPr>
-              <a:t>sl</a:t>
-            </a:r>
-            <a:r>
-              <a:rPr b="0" lang="en-US" sz="4400" spc="-1" strike="noStrike">
-                <a:latin typeface="Arial"/>
-              </a:rPr>
-              <a:t>id</a:t>
-            </a:r>
-            <a:r>
-              <a:rPr b="0" lang="en-US" sz="4400" spc="-1" strike="noStrike">
-                <a:latin typeface="Arial"/>
-              </a:rPr>
-              <a:t>e</a:t>
-            </a:r>
-            <a:endParaRPr b="0" lang="en-US" sz="4400" spc="-1" strike="noStrike">
-              <a:latin typeface="Arial"/>
+            <a:r>
+              <a:rPr b="0" lang="en-US" sz="1800" spc="-1" strike="noStrike">
+                <a:solidFill>
+                  <a:srgbClr val="000000"/>
+                </a:solidFill>
+                <a:latin typeface="Calibri"/>
+              </a:rPr>
+              <a:t>Click to move the slide</a:t>
+            </a:r>
+            <a:endParaRPr b="0" lang="en-US" sz="1800" spc="-1" strike="noStrike">
+              <a:solidFill>
+                <a:srgbClr val="000000"/>
+              </a:solidFill>
+              <a:latin typeface="Calibri"/>
             </a:endParaRPr>
           </a:p>
         </p:txBody>
@@ -379,7 +304,7 @@
             <a:pPr algn="r">
               <a:buNone/>
             </a:pPr>
-            <a:fld id="{56D2D209-DB2E-4240-99A0-541B2FF232F3}" type="slidenum">
+            <a:fld id="{97485102-B76E-4575-BB99-22F61BA8BA90}" type="slidenum">
               <a:rPr b="0" lang="en-US" sz="1400" spc="-1" strike="noStrike">
                 <a:latin typeface="Times New Roman"/>
               </a:rPr>
@@ -416,7 +341,7 @@
       </p:grpSpPr>
       <p:sp>
         <p:nvSpPr>
-          <p:cNvPr id="152" name="PlaceHolder 1"/>
+          <p:cNvPr id="150" name="PlaceHolder 1"/>
           <p:cNvSpPr>
             <a:spLocks noGrp="1"/>
           </p:cNvSpPr>
@@ -439,7 +364,7 @@
       </p:sp>
       <p:sp>
         <p:nvSpPr>
-          <p:cNvPr id="153" name="PlaceHolder 2"/>
+          <p:cNvPr id="151" name="PlaceHolder 2"/>
           <p:cNvSpPr>
             <a:spLocks noGrp="1"/>
           </p:cNvSpPr>
@@ -461,7 +386,7 @@
           </a:ln>
         </p:spPr>
         <p:txBody>
-          <a:bodyPr lIns="90000" rIns="90000" tIns="0" bIns="0" anchor="t">
+          <a:bodyPr lIns="90000" rIns="90000" tIns="90000" bIns="90000" anchor="t">
             <a:noAutofit/>
           </a:bodyPr>
           <a:p>
@@ -473,7 +398,7 @@
       </p:sp>
       <p:sp>
         <p:nvSpPr>
-          <p:cNvPr id="154" name="PlaceHolder 3"/>
+          <p:cNvPr id="152" name="PlaceHolder 3"/>
           <p:cNvSpPr>
             <a:spLocks noGrp="1"/>
           </p:cNvSpPr>
@@ -495,11 +420,11 @@
           </a:ln>
         </p:spPr>
         <p:txBody>
-          <a:bodyPr lIns="90000" rIns="90000" tIns="0" bIns="0" anchor="t">
+          <a:bodyPr lIns="90000" rIns="90000" tIns="90000" bIns="90000" anchor="t">
             <a:noAutofit/>
           </a:bodyPr>
           <a:lstStyle>
-            <a:lvl1pPr algn="r">
+            <a:lvl1pPr>
               <a:lnSpc>
                 <a:spcPct val="100000"/>
               </a:lnSpc>
@@ -514,13 +439,13 @@
             </a:lvl1pPr>
           </a:lstStyle>
           <a:p>
-            <a:pPr algn="r">
+            <a:pPr>
               <a:lnSpc>
                 <a:spcPct val="100000"/>
               </a:lnSpc>
               <a:buNone/>
             </a:pPr>
-            <a:fld id="{D1CECB1B-B1FC-4A52-943F-0DC6556AACBE}" type="slidenum">
+            <a:fld id="{D5F61F92-5985-48DD-9F31-F1439C214E78}" type="slidenum">
               <a:rPr b="0" lang="en-US" sz="1800" spc="-1" strike="noStrike">
                 <a:solidFill>
                   <a:srgbClr val="000000"/>
@@ -560,7 +485,7 @@
       </p:grpSpPr>
       <p:sp>
         <p:nvSpPr>
-          <p:cNvPr id="179" name="PlaceHolder 1"/>
+          <p:cNvPr id="177" name="PlaceHolder 1"/>
           <p:cNvSpPr>
             <a:spLocks noGrp="1"/>
           </p:cNvSpPr>
@@ -583,7 +508,7 @@
       </p:sp>
       <p:sp>
         <p:nvSpPr>
-          <p:cNvPr id="180" name="PlaceHolder 2"/>
+          <p:cNvPr id="178" name="PlaceHolder 2"/>
           <p:cNvSpPr>
             <a:spLocks noGrp="1"/>
           </p:cNvSpPr>
@@ -605,7 +530,7 @@
           </a:ln>
         </p:spPr>
         <p:txBody>
-          <a:bodyPr lIns="90000" rIns="90000" tIns="0" bIns="0" anchor="t">
+          <a:bodyPr lIns="90000" rIns="90000" tIns="90000" bIns="90000" anchor="t">
             <a:noAutofit/>
           </a:bodyPr>
           <a:p>
@@ -617,7 +542,7 @@
       </p:sp>
       <p:sp>
         <p:nvSpPr>
-          <p:cNvPr id="181" name="PlaceHolder 3"/>
+          <p:cNvPr id="179" name="PlaceHolder 3"/>
           <p:cNvSpPr>
             <a:spLocks noGrp="1"/>
           </p:cNvSpPr>
@@ -639,11 +564,11 @@
           </a:ln>
         </p:spPr>
         <p:txBody>
-          <a:bodyPr lIns="90000" rIns="90000" tIns="0" bIns="0" anchor="t">
+          <a:bodyPr lIns="90000" rIns="90000" tIns="90000" bIns="90000" anchor="t">
             <a:noAutofit/>
           </a:bodyPr>
           <a:lstStyle>
-            <a:lvl1pPr algn="r">
+            <a:lvl1pPr>
               <a:lnSpc>
                 <a:spcPct val="100000"/>
               </a:lnSpc>
@@ -658,13 +583,13 @@
             </a:lvl1pPr>
           </a:lstStyle>
           <a:p>
-            <a:pPr algn="r">
+            <a:pPr>
               <a:lnSpc>
                 <a:spcPct val="100000"/>
               </a:lnSpc>
               <a:buNone/>
             </a:pPr>
-            <a:fld id="{2FC4B272-991B-416F-96E0-CFF2A413A14A}" type="slidenum">
+            <a:fld id="{71F04D45-60CC-4319-AB06-1FC8A8C3EDF1}" type="slidenum">
               <a:rPr b="0" lang="en-US" sz="1800" spc="-1" strike="noStrike">
                 <a:solidFill>
                   <a:srgbClr val="000000"/>
@@ -704,7 +629,7 @@
       </p:grpSpPr>
       <p:sp>
         <p:nvSpPr>
-          <p:cNvPr id="155" name="PlaceHolder 1"/>
+          <p:cNvPr id="153" name="PlaceHolder 1"/>
           <p:cNvSpPr>
             <a:spLocks noGrp="1"/>
           </p:cNvSpPr>
@@ -727,7 +652,7 @@
       </p:sp>
       <p:sp>
         <p:nvSpPr>
-          <p:cNvPr id="156" name="PlaceHolder 2"/>
+          <p:cNvPr id="154" name="PlaceHolder 2"/>
           <p:cNvSpPr>
             <a:spLocks noGrp="1"/>
           </p:cNvSpPr>
@@ -749,7 +674,7 @@
           </a:ln>
         </p:spPr>
         <p:txBody>
-          <a:bodyPr lIns="90000" rIns="90000" tIns="0" bIns="0" anchor="t">
+          <a:bodyPr lIns="90000" rIns="90000" tIns="90000" bIns="90000" anchor="t">
             <a:noAutofit/>
           </a:bodyPr>
           <a:p>
@@ -761,7 +686,7 @@
       </p:sp>
       <p:sp>
         <p:nvSpPr>
-          <p:cNvPr id="157" name="PlaceHolder 3"/>
+          <p:cNvPr id="155" name="PlaceHolder 3"/>
           <p:cNvSpPr>
             <a:spLocks noGrp="1"/>
           </p:cNvSpPr>
@@ -783,11 +708,11 @@
           </a:ln>
         </p:spPr>
         <p:txBody>
-          <a:bodyPr lIns="90000" rIns="90000" tIns="0" bIns="0" anchor="t">
+          <a:bodyPr lIns="90000" rIns="90000" tIns="90000" bIns="90000" anchor="t">
             <a:noAutofit/>
           </a:bodyPr>
           <a:lstStyle>
-            <a:lvl1pPr algn="r">
+            <a:lvl1pPr>
               <a:lnSpc>
                 <a:spcPct val="100000"/>
               </a:lnSpc>
@@ -802,13 +727,13 @@
             </a:lvl1pPr>
           </a:lstStyle>
           <a:p>
-            <a:pPr algn="r">
+            <a:pPr>
               <a:lnSpc>
                 <a:spcPct val="100000"/>
               </a:lnSpc>
               <a:buNone/>
             </a:pPr>
-            <a:fld id="{0F00FA10-D469-4E75-B7C1-52A139167738}" type="slidenum">
+            <a:fld id="{AFEC9195-62F6-4688-960B-F96517C76878}" type="slidenum">
               <a:rPr b="0" lang="en-US" sz="1800" spc="-1" strike="noStrike">
                 <a:solidFill>
                   <a:srgbClr val="000000"/>
@@ -848,7 +773,7 @@
       </p:grpSpPr>
       <p:sp>
         <p:nvSpPr>
-          <p:cNvPr id="158" name="PlaceHolder 1"/>
+          <p:cNvPr id="156" name="PlaceHolder 1"/>
           <p:cNvSpPr>
             <a:spLocks noGrp="1"/>
           </p:cNvSpPr>
@@ -871,7 +796,7 @@
       </p:sp>
       <p:sp>
         <p:nvSpPr>
-          <p:cNvPr id="159" name="PlaceHolder 2"/>
+          <p:cNvPr id="157" name="PlaceHolder 2"/>
           <p:cNvSpPr>
             <a:spLocks noGrp="1"/>
           </p:cNvSpPr>
@@ -893,7 +818,7 @@
           </a:ln>
         </p:spPr>
         <p:txBody>
-          <a:bodyPr lIns="90000" rIns="90000" tIns="0" bIns="0" anchor="t">
+          <a:bodyPr lIns="90000" rIns="90000" tIns="90000" bIns="90000" anchor="t">
             <a:noAutofit/>
           </a:bodyPr>
           <a:p>
@@ -905,7 +830,7 @@
       </p:sp>
       <p:sp>
         <p:nvSpPr>
-          <p:cNvPr id="160" name="PlaceHolder 3"/>
+          <p:cNvPr id="158" name="PlaceHolder 3"/>
           <p:cNvSpPr>
             <a:spLocks noGrp="1"/>
           </p:cNvSpPr>
@@ -927,11 +852,11 @@
           </a:ln>
         </p:spPr>
         <p:txBody>
-          <a:bodyPr lIns="90000" rIns="90000" tIns="0" bIns="0" anchor="t">
+          <a:bodyPr lIns="90000" rIns="90000" tIns="90000" bIns="90000" anchor="t">
             <a:noAutofit/>
           </a:bodyPr>
           <a:lstStyle>
-            <a:lvl1pPr algn="r">
+            <a:lvl1pPr>
               <a:lnSpc>
                 <a:spcPct val="100000"/>
               </a:lnSpc>
@@ -946,13 +871,13 @@
             </a:lvl1pPr>
           </a:lstStyle>
           <a:p>
-            <a:pPr algn="r">
+            <a:pPr>
               <a:lnSpc>
                 <a:spcPct val="100000"/>
               </a:lnSpc>
               <a:buNone/>
             </a:pPr>
-            <a:fld id="{5C9A766F-1A84-4C34-A08A-6E53C97FA6FA}" type="slidenum">
+            <a:fld id="{24C3909B-601E-42A0-AA38-C0A83DE27FC9}" type="slidenum">
               <a:rPr b="0" lang="en-US" sz="1800" spc="-1" strike="noStrike">
                 <a:solidFill>
                   <a:srgbClr val="000000"/>
@@ -992,7 +917,7 @@
       </p:grpSpPr>
       <p:sp>
         <p:nvSpPr>
-          <p:cNvPr id="161" name="PlaceHolder 1"/>
+          <p:cNvPr id="159" name="PlaceHolder 1"/>
           <p:cNvSpPr>
             <a:spLocks noGrp="1"/>
           </p:cNvSpPr>
@@ -1015,7 +940,7 @@
       </p:sp>
       <p:sp>
         <p:nvSpPr>
-          <p:cNvPr id="162" name="PlaceHolder 2"/>
+          <p:cNvPr id="160" name="PlaceHolder 2"/>
           <p:cNvSpPr>
             <a:spLocks noGrp="1"/>
           </p:cNvSpPr>
@@ -1037,7 +962,7 @@
           </a:ln>
         </p:spPr>
         <p:txBody>
-          <a:bodyPr lIns="90000" rIns="90000" tIns="0" bIns="0" anchor="t">
+          <a:bodyPr lIns="90000" rIns="90000" tIns="90000" bIns="90000" anchor="t">
             <a:noAutofit/>
           </a:bodyPr>
           <a:p>
@@ -1049,7 +974,7 @@
       </p:sp>
       <p:sp>
         <p:nvSpPr>
-          <p:cNvPr id="163" name="PlaceHolder 3"/>
+          <p:cNvPr id="161" name="PlaceHolder 3"/>
           <p:cNvSpPr>
             <a:spLocks noGrp="1"/>
           </p:cNvSpPr>
@@ -1071,11 +996,11 @@
           </a:ln>
         </p:spPr>
         <p:txBody>
-          <a:bodyPr lIns="90000" rIns="90000" tIns="0" bIns="0" anchor="t">
+          <a:bodyPr lIns="90000" rIns="90000" tIns="90000" bIns="90000" anchor="t">
             <a:noAutofit/>
           </a:bodyPr>
           <a:lstStyle>
-            <a:lvl1pPr algn="r">
+            <a:lvl1pPr>
               <a:lnSpc>
                 <a:spcPct val="100000"/>
               </a:lnSpc>
@@ -1090,13 +1015,13 @@
             </a:lvl1pPr>
           </a:lstStyle>
           <a:p>
-            <a:pPr algn="r">
+            <a:pPr>
               <a:lnSpc>
                 <a:spcPct val="100000"/>
               </a:lnSpc>
               <a:buNone/>
             </a:pPr>
-            <a:fld id="{5D38B008-98E6-4D92-84C9-38DEDE1985D0}" type="slidenum">
+            <a:fld id="{811AC703-0A42-480B-BF75-0686E49FE47A}" type="slidenum">
               <a:rPr b="0" lang="en-US" sz="1800" spc="-1" strike="noStrike">
                 <a:solidFill>
                   <a:srgbClr val="000000"/>
@@ -1136,7 +1061,7 @@
       </p:grpSpPr>
       <p:sp>
         <p:nvSpPr>
-          <p:cNvPr id="164" name="PlaceHolder 1"/>
+          <p:cNvPr id="162" name="PlaceHolder 1"/>
           <p:cNvSpPr>
             <a:spLocks noGrp="1"/>
           </p:cNvSpPr>
@@ -1159,7 +1084,7 @@
       </p:sp>
       <p:sp>
         <p:nvSpPr>
-          <p:cNvPr id="165" name="PlaceHolder 2"/>
+          <p:cNvPr id="163" name="PlaceHolder 2"/>
           <p:cNvSpPr>
             <a:spLocks noGrp="1"/>
           </p:cNvSpPr>
@@ -1181,7 +1106,7 @@
           </a:ln>
         </p:spPr>
         <p:txBody>
-          <a:bodyPr lIns="90000" rIns="90000" tIns="0" bIns="0" anchor="t">
+          <a:bodyPr lIns="90000" rIns="90000" tIns="90000" bIns="90000" anchor="t">
             <a:noAutofit/>
           </a:bodyPr>
           <a:p>
@@ -1193,7 +1118,7 @@
       </p:sp>
       <p:sp>
         <p:nvSpPr>
-          <p:cNvPr id="166" name="PlaceHolder 3"/>
+          <p:cNvPr id="164" name="PlaceHolder 3"/>
           <p:cNvSpPr>
             <a:spLocks noGrp="1"/>
           </p:cNvSpPr>
@@ -1215,11 +1140,11 @@
           </a:ln>
         </p:spPr>
         <p:txBody>
-          <a:bodyPr lIns="90000" rIns="90000" tIns="0" bIns="0" anchor="t">
+          <a:bodyPr lIns="90000" rIns="90000" tIns="90000" bIns="90000" anchor="t">
             <a:noAutofit/>
           </a:bodyPr>
           <a:lstStyle>
-            <a:lvl1pPr algn="r">
+            <a:lvl1pPr>
               <a:lnSpc>
                 <a:spcPct val="100000"/>
               </a:lnSpc>
@@ -1234,13 +1159,13 @@
             </a:lvl1pPr>
           </a:lstStyle>
           <a:p>
-            <a:pPr algn="r">
+            <a:pPr>
               <a:lnSpc>
                 <a:spcPct val="100000"/>
               </a:lnSpc>
               <a:buNone/>
             </a:pPr>
-            <a:fld id="{5CFFA2AA-8DA8-4967-AE71-CFB3FDCF9C2F}" type="slidenum">
+            <a:fld id="{5AA110A3-B76B-44FA-86A5-02813B419812}" type="slidenum">
               <a:rPr b="0" lang="en-US" sz="1800" spc="-1" strike="noStrike">
                 <a:solidFill>
                   <a:srgbClr val="000000"/>
@@ -1280,7 +1205,7 @@
       </p:grpSpPr>
       <p:sp>
         <p:nvSpPr>
-          <p:cNvPr id="167" name="PlaceHolder 1"/>
+          <p:cNvPr id="165" name="PlaceHolder 1"/>
           <p:cNvSpPr>
             <a:spLocks noGrp="1"/>
           </p:cNvSpPr>
@@ -1303,7 +1228,7 @@
       </p:sp>
       <p:sp>
         <p:nvSpPr>
-          <p:cNvPr id="168" name="PlaceHolder 2"/>
+          <p:cNvPr id="166" name="PlaceHolder 2"/>
           <p:cNvSpPr>
             <a:spLocks noGrp="1"/>
           </p:cNvSpPr>
@@ -1325,7 +1250,7 @@
           </a:ln>
         </p:spPr>
         <p:txBody>
-          <a:bodyPr lIns="90000" rIns="90000" tIns="0" bIns="0" anchor="t">
+          <a:bodyPr lIns="90000" rIns="90000" tIns="90000" bIns="90000" anchor="t">
             <a:noAutofit/>
           </a:bodyPr>
           <a:p>
@@ -1337,7 +1262,7 @@
       </p:sp>
       <p:sp>
         <p:nvSpPr>
-          <p:cNvPr id="169" name="PlaceHolder 3"/>
+          <p:cNvPr id="167" name="PlaceHolder 3"/>
           <p:cNvSpPr>
             <a:spLocks noGrp="1"/>
           </p:cNvSpPr>
@@ -1359,11 +1284,11 @@
           </a:ln>
         </p:spPr>
         <p:txBody>
-          <a:bodyPr lIns="90000" rIns="90000" tIns="0" bIns="0" anchor="t">
+          <a:bodyPr lIns="90000" rIns="90000" tIns="90000" bIns="90000" anchor="t">
             <a:noAutofit/>
           </a:bodyPr>
           <a:lstStyle>
-            <a:lvl1pPr algn="r">
+            <a:lvl1pPr>
               <a:lnSpc>
                 <a:spcPct val="100000"/>
               </a:lnSpc>
@@ -1378,13 +1303,13 @@
             </a:lvl1pPr>
           </a:lstStyle>
           <a:p>
-            <a:pPr algn="r">
+            <a:pPr>
               <a:lnSpc>
                 <a:spcPct val="100000"/>
               </a:lnSpc>
               <a:buNone/>
             </a:pPr>
-            <a:fld id="{D4245E70-F8F8-4768-9723-EBCAAF638CA9}" type="slidenum">
+            <a:fld id="{67DC4908-2CD0-46C6-9B74-3F544C50F8D0}" type="slidenum">
               <a:rPr b="0" lang="en-US" sz="1800" spc="-1" strike="noStrike">
                 <a:solidFill>
                   <a:srgbClr val="000000"/>
@@ -1424,7 +1349,7 @@
       </p:grpSpPr>
       <p:sp>
         <p:nvSpPr>
-          <p:cNvPr id="170" name="PlaceHolder 1"/>
+          <p:cNvPr id="168" name="PlaceHolder 1"/>
           <p:cNvSpPr>
             <a:spLocks noGrp="1"/>
           </p:cNvSpPr>
@@ -1447,7 +1372,7 @@
       </p:sp>
       <p:sp>
         <p:nvSpPr>
-          <p:cNvPr id="171" name="PlaceHolder 2"/>
+          <p:cNvPr id="169" name="PlaceHolder 2"/>
           <p:cNvSpPr>
             <a:spLocks noGrp="1"/>
           </p:cNvSpPr>
@@ -1469,7 +1394,7 @@
           </a:ln>
         </p:spPr>
         <p:txBody>
-          <a:bodyPr lIns="90000" rIns="90000" tIns="0" bIns="0" anchor="t">
+          <a:bodyPr lIns="90000" rIns="90000" tIns="90000" bIns="90000" anchor="t">
             <a:noAutofit/>
           </a:bodyPr>
           <a:p>
@@ -1481,7 +1406,7 @@
       </p:sp>
       <p:sp>
         <p:nvSpPr>
-          <p:cNvPr id="172" name="PlaceHolder 3"/>
+          <p:cNvPr id="170" name="PlaceHolder 3"/>
           <p:cNvSpPr>
             <a:spLocks noGrp="1"/>
           </p:cNvSpPr>
@@ -1503,11 +1428,11 @@
           </a:ln>
         </p:spPr>
         <p:txBody>
-          <a:bodyPr lIns="90000" rIns="90000" tIns="0" bIns="0" anchor="t">
+          <a:bodyPr lIns="90000" rIns="90000" tIns="90000" bIns="90000" anchor="t">
             <a:noAutofit/>
           </a:bodyPr>
           <a:lstStyle>
-            <a:lvl1pPr algn="r">
+            <a:lvl1pPr>
               <a:lnSpc>
                 <a:spcPct val="100000"/>
               </a:lnSpc>
@@ -1522,13 +1447,13 @@
             </a:lvl1pPr>
           </a:lstStyle>
           <a:p>
-            <a:pPr algn="r">
+            <a:pPr>
               <a:lnSpc>
                 <a:spcPct val="100000"/>
               </a:lnSpc>
               <a:buNone/>
             </a:pPr>
-            <a:fld id="{9C6ADAEE-CF41-419B-867E-60DA9C6925AC}" type="slidenum">
+            <a:fld id="{A424CF24-9A31-46A3-BBF0-C13454439206}" type="slidenum">
               <a:rPr b="0" lang="en-US" sz="1800" spc="-1" strike="noStrike">
                 <a:solidFill>
                   <a:srgbClr val="000000"/>
@@ -1568,7 +1493,7 @@
       </p:grpSpPr>
       <p:sp>
         <p:nvSpPr>
-          <p:cNvPr id="173" name="PlaceHolder 1"/>
+          <p:cNvPr id="171" name="PlaceHolder 1"/>
           <p:cNvSpPr>
             <a:spLocks noGrp="1"/>
           </p:cNvSpPr>
@@ -1591,7 +1516,7 @@
       </p:sp>
       <p:sp>
         <p:nvSpPr>
-          <p:cNvPr id="174" name="PlaceHolder 2"/>
+          <p:cNvPr id="172" name="PlaceHolder 2"/>
           <p:cNvSpPr>
             <a:spLocks noGrp="1"/>
           </p:cNvSpPr>
@@ -1613,7 +1538,7 @@
           </a:ln>
         </p:spPr>
         <p:txBody>
-          <a:bodyPr lIns="90000" rIns="90000" tIns="0" bIns="0" anchor="t">
+          <a:bodyPr lIns="90000" rIns="90000" tIns="90000" bIns="90000" anchor="t">
             <a:noAutofit/>
           </a:bodyPr>
           <a:p>
@@ -1625,7 +1550,7 @@
       </p:sp>
       <p:sp>
         <p:nvSpPr>
-          <p:cNvPr id="175" name="PlaceHolder 3"/>
+          <p:cNvPr id="173" name="PlaceHolder 3"/>
           <p:cNvSpPr>
             <a:spLocks noGrp="1"/>
           </p:cNvSpPr>
@@ -1647,11 +1572,11 @@
           </a:ln>
         </p:spPr>
         <p:txBody>
-          <a:bodyPr lIns="90000" rIns="90000" tIns="0" bIns="0" anchor="t">
+          <a:bodyPr lIns="90000" rIns="90000" tIns="90000" bIns="90000" anchor="t">
             <a:noAutofit/>
           </a:bodyPr>
           <a:lstStyle>
-            <a:lvl1pPr algn="r">
+            <a:lvl1pPr>
               <a:lnSpc>
                 <a:spcPct val="100000"/>
               </a:lnSpc>
@@ -1666,13 +1591,13 @@
             </a:lvl1pPr>
           </a:lstStyle>
           <a:p>
-            <a:pPr algn="r">
+            <a:pPr>
               <a:lnSpc>
                 <a:spcPct val="100000"/>
               </a:lnSpc>
               <a:buNone/>
             </a:pPr>
-            <a:fld id="{AB665D43-9A09-49F2-8C95-C68DBBC4A84F}" type="slidenum">
+            <a:fld id="{DB686BFD-246D-4D2D-BB94-1B93E4119784}" type="slidenum">
               <a:rPr b="0" lang="en-US" sz="1800" spc="-1" strike="noStrike">
                 <a:solidFill>
                   <a:srgbClr val="000000"/>
@@ -1712,7 +1637,7 @@
       </p:grpSpPr>
       <p:sp>
         <p:nvSpPr>
-          <p:cNvPr id="176" name="PlaceHolder 1"/>
+          <p:cNvPr id="174" name="PlaceHolder 1"/>
           <p:cNvSpPr>
             <a:spLocks noGrp="1"/>
           </p:cNvSpPr>
@@ -1735,7 +1660,7 @@
       </p:sp>
       <p:sp>
         <p:nvSpPr>
-          <p:cNvPr id="177" name="PlaceHolder 2"/>
+          <p:cNvPr id="175" name="PlaceHolder 2"/>
           <p:cNvSpPr>
             <a:spLocks noGrp="1"/>
           </p:cNvSpPr>
@@ -1757,7 +1682,7 @@
           </a:ln>
         </p:spPr>
         <p:txBody>
-          <a:bodyPr lIns="90000" rIns="90000" tIns="0" bIns="0" anchor="t">
+          <a:bodyPr lIns="90000" rIns="90000" tIns="90000" bIns="90000" anchor="t">
             <a:noAutofit/>
           </a:bodyPr>
           <a:p>
@@ -1769,7 +1694,7 @@
       </p:sp>
       <p:sp>
         <p:nvSpPr>
-          <p:cNvPr id="178" name="PlaceHolder 3"/>
+          <p:cNvPr id="176" name="PlaceHolder 3"/>
           <p:cNvSpPr>
             <a:spLocks noGrp="1"/>
           </p:cNvSpPr>
@@ -1791,11 +1716,11 @@
           </a:ln>
         </p:spPr>
         <p:txBody>
-          <a:bodyPr lIns="90000" rIns="90000" tIns="0" bIns="0" anchor="t">
+          <a:bodyPr lIns="90000" rIns="90000" tIns="90000" bIns="90000" anchor="t">
             <a:noAutofit/>
           </a:bodyPr>
           <a:lstStyle>
-            <a:lvl1pPr algn="r">
+            <a:lvl1pPr>
               <a:lnSpc>
                 <a:spcPct val="100000"/>
               </a:lnSpc>
@@ -1810,13 +1735,13 @@
             </a:lvl1pPr>
           </a:lstStyle>
           <a:p>
-            <a:pPr algn="r">
+            <a:pPr>
               <a:lnSpc>
                 <a:spcPct val="100000"/>
               </a:lnSpc>
               <a:buNone/>
             </a:pPr>
-            <a:fld id="{774900D7-60D6-4D1D-8BB0-5B3FEBDAAF11}" type="slidenum">
+            <a:fld id="{59749624-5DD1-472B-AED8-0E2355E708AD}" type="slidenum">
               <a:rPr b="0" lang="en-US" sz="1800" spc="-1" strike="noStrike">
                 <a:solidFill>
                   <a:srgbClr val="000000"/>
@@ -1904,11 +1829,11 @@
             <a:noAutofit/>
           </a:bodyPr>
           <a:p>
-            <a:pPr algn="ctr">
-              <a:buNone/>
-            </a:pPr>
-            <a:endParaRPr b="0" lang="en-US" sz="4400" spc="-1" strike="noStrike">
-              <a:latin typeface="Arial"/>
+            <a:endParaRPr b="0" lang="en-US" sz="1800" spc="-1" strike="noStrike">
+              <a:solidFill>
+                <a:srgbClr val="000000"/>
+              </a:solidFill>
+              <a:latin typeface="Calibri"/>
             </a:endParaRPr>
           </a:p>
         </p:txBody>
@@ -1942,7 +1867,10 @@
           </a:bodyPr>
           <a:p>
             <a:endParaRPr b="0" lang="en-US" sz="3200" spc="-1" strike="noStrike">
-              <a:latin typeface="Arial"/>
+              <a:solidFill>
+                <a:srgbClr val="000000"/>
+              </a:solidFill>
+              <a:latin typeface="Calibri"/>
             </a:endParaRPr>
           </a:p>
         </p:txBody>
@@ -1976,7 +1904,10 @@
           </a:bodyPr>
           <a:p>
             <a:endParaRPr b="0" lang="en-US" sz="3200" spc="-1" strike="noStrike">
-              <a:latin typeface="Arial"/>
+              <a:solidFill>
+                <a:srgbClr val="000000"/>
+              </a:solidFill>
+              <a:latin typeface="Calibri"/>
             </a:endParaRPr>
           </a:p>
         </p:txBody>
@@ -2031,11 +1962,11 @@
             <a:noAutofit/>
           </a:bodyPr>
           <a:p>
-            <a:pPr algn="ctr">
-              <a:buNone/>
-            </a:pPr>
-            <a:endParaRPr b="0" lang="en-US" sz="4400" spc="-1" strike="noStrike">
-              <a:latin typeface="Arial"/>
+            <a:endParaRPr b="0" lang="en-US" sz="1800" spc="-1" strike="noStrike">
+              <a:solidFill>
+                <a:srgbClr val="000000"/>
+              </a:solidFill>
+              <a:latin typeface="Calibri"/>
             </a:endParaRPr>
           </a:p>
         </p:txBody>
@@ -2069,7 +2000,10 @@
           </a:bodyPr>
           <a:p>
             <a:endParaRPr b="0" lang="en-US" sz="3200" spc="-1" strike="noStrike">
-              <a:latin typeface="Arial"/>
+              <a:solidFill>
+                <a:srgbClr val="000000"/>
+              </a:solidFill>
+              <a:latin typeface="Calibri"/>
             </a:endParaRPr>
           </a:p>
         </p:txBody>
@@ -2103,7 +2037,10 @@
           </a:bodyPr>
           <a:p>
             <a:endParaRPr b="0" lang="en-US" sz="3200" spc="-1" strike="noStrike">
-              <a:latin typeface="Arial"/>
+              <a:solidFill>
+                <a:srgbClr val="000000"/>
+              </a:solidFill>
+              <a:latin typeface="Calibri"/>
             </a:endParaRPr>
           </a:p>
         </p:txBody>
@@ -2137,7 +2074,10 @@
           </a:bodyPr>
           <a:p>
             <a:endParaRPr b="0" lang="en-US" sz="3200" spc="-1" strike="noStrike">
-              <a:latin typeface="Arial"/>
+              <a:solidFill>
+                <a:srgbClr val="000000"/>
+              </a:solidFill>
+              <a:latin typeface="Calibri"/>
             </a:endParaRPr>
           </a:p>
         </p:txBody>
@@ -2171,7 +2111,10 @@
           </a:bodyPr>
           <a:p>
             <a:endParaRPr b="0" lang="en-US" sz="3200" spc="-1" strike="noStrike">
-              <a:latin typeface="Arial"/>
+              <a:solidFill>
+                <a:srgbClr val="000000"/>
+              </a:solidFill>
+              <a:latin typeface="Calibri"/>
             </a:endParaRPr>
           </a:p>
         </p:txBody>
@@ -2226,11 +2169,11 @@
             <a:noAutofit/>
           </a:bodyPr>
           <a:p>
-            <a:pPr algn="ctr">
-              <a:buNone/>
-            </a:pPr>
-            <a:endParaRPr b="0" lang="en-US" sz="4400" spc="-1" strike="noStrike">
-              <a:latin typeface="Arial"/>
+            <a:endParaRPr b="0" lang="en-US" sz="1800" spc="-1" strike="noStrike">
+              <a:solidFill>
+                <a:srgbClr val="000000"/>
+              </a:solidFill>
+              <a:latin typeface="Calibri"/>
             </a:endParaRPr>
           </a:p>
         </p:txBody>
@@ -2264,7 +2207,10 @@
           </a:bodyPr>
           <a:p>
             <a:endParaRPr b="0" lang="en-US" sz="3200" spc="-1" strike="noStrike">
-              <a:latin typeface="Arial"/>
+              <a:solidFill>
+                <a:srgbClr val="000000"/>
+              </a:solidFill>
+              <a:latin typeface="Calibri"/>
             </a:endParaRPr>
           </a:p>
         </p:txBody>
@@ -2298,7 +2244,10 @@
           </a:bodyPr>
           <a:p>
             <a:endParaRPr b="0" lang="en-US" sz="3200" spc="-1" strike="noStrike">
-              <a:latin typeface="Arial"/>
+              <a:solidFill>
+                <a:srgbClr val="000000"/>
+              </a:solidFill>
+              <a:latin typeface="Calibri"/>
             </a:endParaRPr>
           </a:p>
         </p:txBody>
@@ -2332,7 +2281,10 @@
           </a:bodyPr>
           <a:p>
             <a:endParaRPr b="0" lang="en-US" sz="3200" spc="-1" strike="noStrike">
-              <a:latin typeface="Arial"/>
+              <a:solidFill>
+                <a:srgbClr val="000000"/>
+              </a:solidFill>
+              <a:latin typeface="Calibri"/>
             </a:endParaRPr>
           </a:p>
         </p:txBody>
@@ -2366,7 +2318,10 @@
           </a:bodyPr>
           <a:p>
             <a:endParaRPr b="0" lang="en-US" sz="3200" spc="-1" strike="noStrike">
-              <a:latin typeface="Arial"/>
+              <a:solidFill>
+                <a:srgbClr val="000000"/>
+              </a:solidFill>
+              <a:latin typeface="Calibri"/>
             </a:endParaRPr>
           </a:p>
         </p:txBody>
@@ -2400,7 +2355,10 @@
           </a:bodyPr>
           <a:p>
             <a:endParaRPr b="0" lang="en-US" sz="3200" spc="-1" strike="noStrike">
-              <a:latin typeface="Arial"/>
+              <a:solidFill>
+                <a:srgbClr val="000000"/>
+              </a:solidFill>
+              <a:latin typeface="Calibri"/>
             </a:endParaRPr>
           </a:p>
         </p:txBody>
@@ -2434,7 +2392,10 @@
           </a:bodyPr>
           <a:p>
             <a:endParaRPr b="0" lang="en-US" sz="3200" spc="-1" strike="noStrike">
-              <a:latin typeface="Arial"/>
+              <a:solidFill>
+                <a:srgbClr val="000000"/>
+              </a:solidFill>
+              <a:latin typeface="Calibri"/>
             </a:endParaRPr>
           </a:p>
         </p:txBody>
@@ -2489,11 +2450,11 @@
             <a:noAutofit/>
           </a:bodyPr>
           <a:p>
-            <a:pPr algn="ctr">
-              <a:buNone/>
-            </a:pPr>
-            <a:endParaRPr b="0" lang="en-US" sz="4400" spc="-1" strike="noStrike">
-              <a:latin typeface="Arial"/>
+            <a:endParaRPr b="0" lang="en-US" sz="1800" spc="-1" strike="noStrike">
+              <a:solidFill>
+                <a:srgbClr val="000000"/>
+              </a:solidFill>
+              <a:latin typeface="Calibri"/>
             </a:endParaRPr>
           </a:p>
         </p:txBody>
@@ -2585,11 +2546,11 @@
             <a:noAutofit/>
           </a:bodyPr>
           <a:p>
-            <a:pPr algn="ctr">
-              <a:buNone/>
-            </a:pPr>
-            <a:endParaRPr b="0" lang="en-US" sz="4400" spc="-1" strike="noStrike">
-              <a:latin typeface="Arial"/>
+            <a:endParaRPr b="0" lang="en-US" sz="1800" spc="-1" strike="noStrike">
+              <a:solidFill>
+                <a:srgbClr val="000000"/>
+              </a:solidFill>
+              <a:latin typeface="Calibri"/>
             </a:endParaRPr>
           </a:p>
         </p:txBody>
@@ -2623,7 +2584,10 @@
           </a:bodyPr>
           <a:p>
             <a:endParaRPr b="0" lang="en-US" sz="3200" spc="-1" strike="noStrike">
-              <a:latin typeface="Arial"/>
+              <a:solidFill>
+                <a:srgbClr val="000000"/>
+              </a:solidFill>
+              <a:latin typeface="Calibri"/>
             </a:endParaRPr>
           </a:p>
         </p:txBody>
@@ -2678,11 +2642,11 @@
             <a:noAutofit/>
           </a:bodyPr>
           <a:p>
-            <a:pPr algn="ctr">
-              <a:buNone/>
-            </a:pPr>
-            <a:endParaRPr b="0" lang="en-US" sz="4400" spc="-1" strike="noStrike">
-              <a:latin typeface="Arial"/>
+            <a:endParaRPr b="0" lang="en-US" sz="1800" spc="-1" strike="noStrike">
+              <a:solidFill>
+                <a:srgbClr val="000000"/>
+              </a:solidFill>
+              <a:latin typeface="Calibri"/>
             </a:endParaRPr>
           </a:p>
         </p:txBody>
@@ -2716,7 +2680,10 @@
           </a:bodyPr>
           <a:p>
             <a:endParaRPr b="0" lang="en-US" sz="3200" spc="-1" strike="noStrike">
-              <a:latin typeface="Arial"/>
+              <a:solidFill>
+                <a:srgbClr val="000000"/>
+              </a:solidFill>
+              <a:latin typeface="Calibri"/>
             </a:endParaRPr>
           </a:p>
         </p:txBody>
@@ -2750,7 +2717,10 @@
           </a:bodyPr>
           <a:p>
             <a:endParaRPr b="0" lang="en-US" sz="3200" spc="-1" strike="noStrike">
-              <a:latin typeface="Arial"/>
+              <a:solidFill>
+                <a:srgbClr val="000000"/>
+              </a:solidFill>
+              <a:latin typeface="Calibri"/>
             </a:endParaRPr>
           </a:p>
         </p:txBody>
@@ -2805,11 +2775,11 @@
             <a:noAutofit/>
           </a:bodyPr>
           <a:p>
-            <a:pPr algn="ctr">
-              <a:buNone/>
-            </a:pPr>
-            <a:endParaRPr b="0" lang="en-US" sz="4400" spc="-1" strike="noStrike">
-              <a:latin typeface="Arial"/>
+            <a:endParaRPr b="0" lang="en-US" sz="1800" spc="-1" strike="noStrike">
+              <a:solidFill>
+                <a:srgbClr val="000000"/>
+              </a:solidFill>
+              <a:latin typeface="Calibri"/>
             </a:endParaRPr>
           </a:p>
         </p:txBody>
@@ -2923,11 +2893,11 @@
             <a:noAutofit/>
           </a:bodyPr>
           <a:p>
-            <a:pPr algn="ctr">
-              <a:buNone/>
-            </a:pPr>
-            <a:endParaRPr b="0" lang="en-US" sz="4400" spc="-1" strike="noStrike">
-              <a:latin typeface="Arial"/>
+            <a:endParaRPr b="0" lang="en-US" sz="1800" spc="-1" strike="noStrike">
+              <a:solidFill>
+                <a:srgbClr val="000000"/>
+              </a:solidFill>
+              <a:latin typeface="Calibri"/>
             </a:endParaRPr>
           </a:p>
         </p:txBody>
@@ -2961,7 +2931,10 @@
           </a:bodyPr>
           <a:p>
             <a:endParaRPr b="0" lang="en-US" sz="3200" spc="-1" strike="noStrike">
-              <a:latin typeface="Arial"/>
+              <a:solidFill>
+                <a:srgbClr val="000000"/>
+              </a:solidFill>
+              <a:latin typeface="Calibri"/>
             </a:endParaRPr>
           </a:p>
         </p:txBody>
@@ -2995,7 +2968,10 @@
           </a:bodyPr>
           <a:p>
             <a:endParaRPr b="0" lang="en-US" sz="3200" spc="-1" strike="noStrike">
-              <a:latin typeface="Arial"/>
+              <a:solidFill>
+                <a:srgbClr val="000000"/>
+              </a:solidFill>
+              <a:latin typeface="Calibri"/>
             </a:endParaRPr>
           </a:p>
         </p:txBody>
@@ -3029,7 +3005,10 @@
           </a:bodyPr>
           <a:p>
             <a:endParaRPr b="0" lang="en-US" sz="3200" spc="-1" strike="noStrike">
-              <a:latin typeface="Arial"/>
+              <a:solidFill>
+                <a:srgbClr val="000000"/>
+              </a:solidFill>
+              <a:latin typeface="Calibri"/>
             </a:endParaRPr>
           </a:p>
         </p:txBody>
@@ -3084,11 +3063,11 @@
             <a:noAutofit/>
           </a:bodyPr>
           <a:p>
-            <a:pPr algn="ctr">
-              <a:buNone/>
-            </a:pPr>
-            <a:endParaRPr b="0" lang="en-US" sz="4400" spc="-1" strike="noStrike">
-              <a:latin typeface="Arial"/>
+            <a:endParaRPr b="0" lang="en-US" sz="1800" spc="-1" strike="noStrike">
+              <a:solidFill>
+                <a:srgbClr val="000000"/>
+              </a:solidFill>
+              <a:latin typeface="Calibri"/>
             </a:endParaRPr>
           </a:p>
         </p:txBody>
@@ -3122,7 +3101,10 @@
           </a:bodyPr>
           <a:p>
             <a:endParaRPr b="0" lang="en-US" sz="3200" spc="-1" strike="noStrike">
-              <a:latin typeface="Arial"/>
+              <a:solidFill>
+                <a:srgbClr val="000000"/>
+              </a:solidFill>
+              <a:latin typeface="Calibri"/>
             </a:endParaRPr>
           </a:p>
         </p:txBody>
@@ -3156,7 +3138,10 @@
           </a:bodyPr>
           <a:p>
             <a:endParaRPr b="0" lang="en-US" sz="3200" spc="-1" strike="noStrike">
-              <a:latin typeface="Arial"/>
+              <a:solidFill>
+                <a:srgbClr val="000000"/>
+              </a:solidFill>
+              <a:latin typeface="Calibri"/>
             </a:endParaRPr>
           </a:p>
         </p:txBody>
@@ -3190,7 +3175,10 @@
           </a:bodyPr>
           <a:p>
             <a:endParaRPr b="0" lang="en-US" sz="3200" spc="-1" strike="noStrike">
-              <a:latin typeface="Arial"/>
+              <a:solidFill>
+                <a:srgbClr val="000000"/>
+              </a:solidFill>
+              <a:latin typeface="Calibri"/>
             </a:endParaRPr>
           </a:p>
         </p:txBody>
@@ -3245,11 +3233,11 @@
             <a:noAutofit/>
           </a:bodyPr>
           <a:p>
-            <a:pPr algn="ctr">
-              <a:buNone/>
-            </a:pPr>
-            <a:endParaRPr b="0" lang="en-US" sz="4400" spc="-1" strike="noStrike">
-              <a:latin typeface="Arial"/>
+            <a:endParaRPr b="0" lang="en-US" sz="1800" spc="-1" strike="noStrike">
+              <a:solidFill>
+                <a:srgbClr val="000000"/>
+              </a:solidFill>
+              <a:latin typeface="Calibri"/>
             </a:endParaRPr>
           </a:p>
         </p:txBody>
@@ -3283,7 +3271,10 @@
           </a:bodyPr>
           <a:p>
             <a:endParaRPr b="0" lang="en-US" sz="3200" spc="-1" strike="noStrike">
-              <a:latin typeface="Arial"/>
+              <a:solidFill>
+                <a:srgbClr val="000000"/>
+              </a:solidFill>
+              <a:latin typeface="Calibri"/>
             </a:endParaRPr>
           </a:p>
         </p:txBody>
@@ -3317,7 +3308,10 @@
           </a:bodyPr>
           <a:p>
             <a:endParaRPr b="0" lang="en-US" sz="3200" spc="-1" strike="noStrike">
-              <a:latin typeface="Arial"/>
+              <a:solidFill>
+                <a:srgbClr val="000000"/>
+              </a:solidFill>
+              <a:latin typeface="Calibri"/>
             </a:endParaRPr>
           </a:p>
         </p:txBody>
@@ -3351,7 +3345,10 @@
           </a:bodyPr>
           <a:p>
             <a:endParaRPr b="0" lang="en-US" sz="3200" spc="-1" strike="noStrike">
-              <a:latin typeface="Arial"/>
+              <a:solidFill>
+                <a:srgbClr val="000000"/>
+              </a:solidFill>
+              <a:latin typeface="Calibri"/>
             </a:endParaRPr>
           </a:p>
         </p:txBody>
@@ -3413,29 +3410,20 @@
             <a:noAutofit/>
           </a:bodyPr>
           <a:p>
-            <a:pPr algn="ctr">
-              <a:buNone/>
-            </a:pPr>
-            <a:r>
-              <a:rPr b="0" lang="en-US" sz="4400" spc="-1" strike="noStrike">
-                <a:latin typeface="Arial"/>
-              </a:rPr>
-              <a:t>Click to edit </a:t>
-            </a:r>
-            <a:r>
-              <a:rPr b="0" lang="en-US" sz="4400" spc="-1" strike="noStrike">
-                <a:latin typeface="Arial"/>
-              </a:rPr>
-              <a:t>the title text </a:t>
-            </a:r>
-            <a:r>
-              <a:rPr b="0" lang="en-US" sz="4400" spc="-1" strike="noStrike">
-                <a:latin typeface="Arial"/>
-              </a:rPr>
-              <a:t>format</a:t>
-            </a:r>
-            <a:endParaRPr b="0" lang="en-US" sz="4400" spc="-1" strike="noStrike">
-              <a:latin typeface="Arial"/>
+            <a:r>
+              <a:rPr b="0" lang="en-US" sz="1800" spc="-1" strike="noStrike">
+                <a:solidFill>
+                  <a:srgbClr val="000000"/>
+                </a:solidFill>
+                <a:latin typeface="Calibri"/>
+              </a:rPr>
+              <a:t>Click to edit the title text format</a:t>
+            </a:r>
+            <a:endParaRPr b="0" lang="en-US" sz="1800" spc="-1" strike="noStrike">
+              <a:solidFill>
+                <a:srgbClr val="000000"/>
+              </a:solidFill>
+              <a:latin typeface="Calibri"/>
             </a:endParaRPr>
           </a:p>
         </p:txBody>
@@ -3481,12 +3469,18 @@
             </a:pPr>
             <a:r>
               <a:rPr b="0" lang="en-US" sz="3200" spc="-1" strike="noStrike">
-                <a:latin typeface="Arial"/>
+                <a:solidFill>
+                  <a:srgbClr val="000000"/>
+                </a:solidFill>
+                <a:latin typeface="Calibri"/>
               </a:rPr>
               <a:t>Click to edit the outline text format</a:t>
             </a:r>
             <a:endParaRPr b="0" lang="en-US" sz="3200" spc="-1" strike="noStrike">
-              <a:latin typeface="Arial"/>
+              <a:solidFill>
+                <a:srgbClr val="000000"/>
+              </a:solidFill>
+              <a:latin typeface="Calibri"/>
             </a:endParaRPr>
           </a:p>
           <a:p>
@@ -3502,13 +3496,19 @@
               <a:buChar char=""/>
             </a:pPr>
             <a:r>
-              <a:rPr b="0" lang="en-US" sz="2800" spc="-1" strike="noStrike">
-                <a:latin typeface="Arial"/>
+              <a:rPr b="0" lang="en-US" sz="2400" spc="-1" strike="noStrike">
+                <a:solidFill>
+                  <a:srgbClr val="000000"/>
+                </a:solidFill>
+                <a:latin typeface="Calibri"/>
               </a:rPr>
               <a:t>Second Outline Level</a:t>
             </a:r>
-            <a:endParaRPr b="0" lang="en-US" sz="2800" spc="-1" strike="noStrike">
-              <a:latin typeface="Arial"/>
+            <a:endParaRPr b="0" lang="en-US" sz="2400" spc="-1" strike="noStrike">
+              <a:solidFill>
+                <a:srgbClr val="000000"/>
+              </a:solidFill>
+              <a:latin typeface="Calibri"/>
             </a:endParaRPr>
           </a:p>
           <a:p>
@@ -3524,13 +3524,19 @@
               <a:buChar char=""/>
             </a:pPr>
             <a:r>
-              <a:rPr b="0" lang="en-US" sz="2400" spc="-1" strike="noStrike">
-                <a:latin typeface="Arial"/>
+              <a:rPr b="0" lang="en-US" sz="2000" spc="-1" strike="noStrike">
+                <a:solidFill>
+                  <a:srgbClr val="000000"/>
+                </a:solidFill>
+                <a:latin typeface="Calibri"/>
               </a:rPr>
               <a:t>Third Outline Level</a:t>
             </a:r>
-            <a:endParaRPr b="0" lang="en-US" sz="2400" spc="-1" strike="noStrike">
-              <a:latin typeface="Arial"/>
+            <a:endParaRPr b="0" lang="en-US" sz="2000" spc="-1" strike="noStrike">
+              <a:solidFill>
+                <a:srgbClr val="000000"/>
+              </a:solidFill>
+              <a:latin typeface="Calibri"/>
             </a:endParaRPr>
           </a:p>
           <a:p>
@@ -3547,12 +3553,18 @@
             </a:pPr>
             <a:r>
               <a:rPr b="0" lang="en-US" sz="2000" spc="-1" strike="noStrike">
-                <a:latin typeface="Arial"/>
+                <a:solidFill>
+                  <a:srgbClr val="000000"/>
+                </a:solidFill>
+                <a:latin typeface="Calibri"/>
               </a:rPr>
               <a:t>Fourth Outline Level</a:t>
             </a:r>
             <a:endParaRPr b="0" lang="en-US" sz="2000" spc="-1" strike="noStrike">
-              <a:latin typeface="Arial"/>
+              <a:solidFill>
+                <a:srgbClr val="000000"/>
+              </a:solidFill>
+              <a:latin typeface="Calibri"/>
             </a:endParaRPr>
           </a:p>
           <a:p>
@@ -3569,12 +3581,18 @@
             </a:pPr>
             <a:r>
               <a:rPr b="0" lang="en-US" sz="2000" spc="-1" strike="noStrike">
-                <a:latin typeface="Arial"/>
+                <a:solidFill>
+                  <a:srgbClr val="000000"/>
+                </a:solidFill>
+                <a:latin typeface="Calibri"/>
               </a:rPr>
               <a:t>Fifth Outline Level</a:t>
             </a:r>
             <a:endParaRPr b="0" lang="en-US" sz="2000" spc="-1" strike="noStrike">
-              <a:latin typeface="Arial"/>
+              <a:solidFill>
+                <a:srgbClr val="000000"/>
+              </a:solidFill>
+              <a:latin typeface="Calibri"/>
             </a:endParaRPr>
           </a:p>
           <a:p>
@@ -3591,12 +3609,18 @@
             </a:pPr>
             <a:r>
               <a:rPr b="0" lang="en-US" sz="2000" spc="-1" strike="noStrike">
-                <a:latin typeface="Arial"/>
+                <a:solidFill>
+                  <a:srgbClr val="000000"/>
+                </a:solidFill>
+                <a:latin typeface="Calibri"/>
               </a:rPr>
               <a:t>Sixth Outline Level</a:t>
             </a:r>
             <a:endParaRPr b="0" lang="en-US" sz="2000" spc="-1" strike="noStrike">
-              <a:latin typeface="Arial"/>
+              <a:solidFill>
+                <a:srgbClr val="000000"/>
+              </a:solidFill>
+              <a:latin typeface="Calibri"/>
             </a:endParaRPr>
           </a:p>
           <a:p>
@@ -3613,12 +3637,18 @@
             </a:pPr>
             <a:r>
               <a:rPr b="0" lang="en-US" sz="2000" spc="-1" strike="noStrike">
-                <a:latin typeface="Arial"/>
+                <a:solidFill>
+                  <a:srgbClr val="000000"/>
+                </a:solidFill>
+                <a:latin typeface="Calibri"/>
               </a:rPr>
               <a:t>Seventh Outline Level</a:t>
             </a:r>
             <a:endParaRPr b="0" lang="en-US" sz="2000" spc="-1" strike="noStrike">
-              <a:latin typeface="Arial"/>
+              <a:solidFill>
+                <a:srgbClr val="000000"/>
+              </a:solidFill>
+              <a:latin typeface="Calibri"/>
             </a:endParaRPr>
           </a:p>
         </p:txBody>
@@ -3680,7 +3710,7 @@
         <p:spPr>
           <a:xfrm>
             <a:off x="11228760" y="5897880"/>
-            <a:ext cx="502200" cy="502200"/>
+            <a:ext cx="502560" cy="502560"/>
           </a:xfrm>
           <a:prstGeom prst="rect">
             <a:avLst/>
@@ -3699,7 +3729,7 @@
         <p:spPr>
           <a:xfrm>
             <a:off x="11228760" y="5897880"/>
-            <a:ext cx="502200" cy="502200"/>
+            <a:ext cx="502560" cy="502560"/>
           </a:xfrm>
           <a:prstGeom prst="rect">
             <a:avLst/>
@@ -3754,7 +3784,7 @@
         <p:spPr>
           <a:xfrm>
             <a:off x="457200" y="4027680"/>
-            <a:ext cx="10743840" cy="2030400"/>
+            <a:ext cx="10928880" cy="2030760"/>
           </a:xfrm>
           <a:prstGeom prst="rect">
             <a:avLst/>
@@ -3785,7 +3815,7 @@
               </a:tabLst>
             </a:pPr>
             <a:r>
-              <a:rPr b="1" lang="en-US" sz="4000" spc="-1" strike="noStrike">
+              <a:rPr b="1" lang="en-US" sz="4800" spc="-1" strike="noStrike">
                 <a:solidFill>
                   <a:srgbClr val="ffffff"/>
                 </a:solidFill>
@@ -3794,7 +3824,7 @@
               </a:rPr>
               <a:t>TITLE</a:t>
             </a:r>
-            <a:endParaRPr b="0" lang="en-US" sz="4000" spc="-1" strike="noStrike">
+            <a:endParaRPr b="0" lang="en-US" sz="4800" spc="-1" strike="noStrike">
               <a:latin typeface="Arial"/>
             </a:endParaRPr>
           </a:p>
@@ -3813,7 +3843,7 @@
         <p:spPr>
           <a:xfrm>
             <a:off x="457200" y="3692160"/>
-            <a:ext cx="1553760" cy="171720"/>
+            <a:ext cx="1554120" cy="172080"/>
           </a:xfrm>
           <a:prstGeom prst="rect">
             <a:avLst/>
@@ -3862,7 +3892,7 @@
       </p:grpSpPr>
       <p:pic>
         <p:nvPicPr>
-          <p:cNvPr id="150" name="Градиент_Фон" descr="/home/claude/vistas/assets/grad_full_diagonal.png"/>
+          <p:cNvPr id="148" name="Градиент_Фон" descr="/home/claude/vistas/assets/grad_full_diagonal.png"/>
           <p:cNvPicPr/>
           <p:nvPr/>
         </p:nvPicPr>
@@ -3873,7 +3903,7 @@
         <p:spPr>
           <a:xfrm>
             <a:off x="0" y="0"/>
-            <a:ext cx="12188160" cy="6857280"/>
+            <a:ext cx="12188520" cy="6857640"/>
           </a:xfrm>
           <a:prstGeom prst="rect">
             <a:avLst/>
@@ -3885,14 +3915,14 @@
       </p:pic>
       <p:sp>
         <p:nvSpPr>
-          <p:cNvPr id="151" name="TITLE"/>
+          <p:cNvPr id="149" name="TITLE"/>
           <p:cNvSpPr/>
           <p:nvPr/>
         </p:nvSpPr>
         <p:spPr>
           <a:xfrm>
             <a:off x="822960" y="2011680"/>
-            <a:ext cx="10617120" cy="1828080"/>
+            <a:ext cx="10617480" cy="1828440"/>
           </a:xfrm>
           <a:prstGeom prst="rect">
             <a:avLst/>
@@ -3984,7 +4014,7 @@
         <p:spPr>
           <a:xfrm>
             <a:off x="6492240" y="1463040"/>
-            <a:ext cx="5238720" cy="4937040"/>
+            <a:ext cx="5239080" cy="4937400"/>
           </a:xfrm>
           <a:prstGeom prst="roundRect">
             <a:avLst>
@@ -4026,7 +4056,6 @@
                   <a:srgbClr val="ffffff"/>
                 </a:solidFill>
                 <a:latin typeface="Calibri"/>
-                <a:ea typeface="DejaVu Sans"/>
               </a:rPr>
               <a:t>PIC</a:t>
             </a:r>
@@ -4049,7 +4078,7 @@
         <p:spPr>
           <a:xfrm>
             <a:off x="11228760" y="5897880"/>
-            <a:ext cx="502200" cy="502200"/>
+            <a:ext cx="502560" cy="502560"/>
           </a:xfrm>
           <a:prstGeom prst="rect">
             <a:avLst/>
@@ -4068,7 +4097,7 @@
         <p:spPr>
           <a:xfrm>
             <a:off x="11228760" y="5897880"/>
-            <a:ext cx="502200" cy="502200"/>
+            <a:ext cx="502560" cy="502560"/>
           </a:xfrm>
           <a:prstGeom prst="rect">
             <a:avLst/>
@@ -4123,7 +4152,7 @@
         <p:spPr>
           <a:xfrm>
             <a:off x="640080" y="1463040"/>
-            <a:ext cx="5453640" cy="550440"/>
+            <a:ext cx="5454000" cy="550800"/>
           </a:xfrm>
           <a:prstGeom prst="rect">
             <a:avLst/>
@@ -4185,7 +4214,7 @@
         <p:spPr>
           <a:xfrm>
             <a:off x="640080" y="1998720"/>
-            <a:ext cx="5460840" cy="1101960"/>
+            <a:ext cx="5461200" cy="1102320"/>
           </a:xfrm>
           <a:prstGeom prst="rect">
             <a:avLst/>
@@ -4247,7 +4276,7 @@
         <p:spPr>
           <a:xfrm>
             <a:off x="636480" y="3128040"/>
-            <a:ext cx="5453640" cy="550440"/>
+            <a:ext cx="5454000" cy="550800"/>
           </a:xfrm>
           <a:prstGeom prst="rect">
             <a:avLst/>
@@ -4299,7 +4328,7 @@
         <p:spPr>
           <a:xfrm>
             <a:off x="636480" y="3660840"/>
-            <a:ext cx="5460840" cy="1176480"/>
+            <a:ext cx="5461200" cy="1176840"/>
           </a:xfrm>
           <a:prstGeom prst="rect">
             <a:avLst/>
@@ -4361,7 +4390,7 @@
         <p:spPr>
           <a:xfrm>
             <a:off x="636480" y="4843800"/>
-            <a:ext cx="5453640" cy="550440"/>
+            <a:ext cx="5454000" cy="550800"/>
           </a:xfrm>
           <a:prstGeom prst="rect">
             <a:avLst/>
@@ -4413,7 +4442,7 @@
         <p:spPr>
           <a:xfrm>
             <a:off x="636480" y="5376600"/>
-            <a:ext cx="5460840" cy="1108800"/>
+            <a:ext cx="5461200" cy="1109160"/>
           </a:xfrm>
           <a:prstGeom prst="rect">
             <a:avLst/>
@@ -4475,7 +4504,7 @@
         <p:spPr>
           <a:xfrm>
             <a:off x="640080" y="365760"/>
-            <a:ext cx="11090880" cy="972360"/>
+            <a:ext cx="11091240" cy="972720"/>
           </a:xfrm>
           <a:prstGeom prst="rect">
             <a:avLst/>
@@ -4571,7 +4600,7 @@
         <p:spPr>
           <a:xfrm>
             <a:off x="11228760" y="5897880"/>
-            <a:ext cx="502200" cy="502200"/>
+            <a:ext cx="502560" cy="502560"/>
           </a:xfrm>
           <a:prstGeom prst="rect">
             <a:avLst/>
@@ -4590,7 +4619,7 @@
         <p:spPr>
           <a:xfrm>
             <a:off x="11228760" y="5897880"/>
-            <a:ext cx="502200" cy="502200"/>
+            <a:ext cx="502560" cy="502560"/>
           </a:xfrm>
           <a:prstGeom prst="rect">
             <a:avLst/>
@@ -4645,7 +4674,7 @@
         <p:spPr>
           <a:xfrm>
             <a:off x="640080" y="365760"/>
-            <a:ext cx="10908000" cy="1073880"/>
+            <a:ext cx="10908360" cy="1074240"/>
           </a:xfrm>
           <a:prstGeom prst="rect">
             <a:avLst/>
@@ -4700,7 +4729,7 @@
         <p:spPr>
           <a:xfrm>
             <a:off x="640080" y="2309040"/>
-            <a:ext cx="639360" cy="639360"/>
+            <a:ext cx="639720" cy="639720"/>
           </a:xfrm>
           <a:prstGeom prst="roundRect">
             <a:avLst>
@@ -4737,7 +4766,7 @@
         <p:spPr>
           <a:xfrm>
             <a:off x="804600" y="2473560"/>
-            <a:ext cx="310320" cy="310320"/>
+            <a:ext cx="310680" cy="310680"/>
           </a:xfrm>
           <a:prstGeom prst="rect">
             <a:avLst/>
@@ -4756,7 +4785,7 @@
         <p:spPr>
           <a:xfrm>
             <a:off x="640080" y="3223440"/>
-            <a:ext cx="3336840" cy="891000"/>
+            <a:ext cx="3337200" cy="891360"/>
           </a:xfrm>
           <a:prstGeom prst="rect">
             <a:avLst/>
@@ -4811,7 +4840,7 @@
         <p:spPr>
           <a:xfrm>
             <a:off x="640080" y="4114800"/>
-            <a:ext cx="3153960" cy="2193840"/>
+            <a:ext cx="3154320" cy="2194200"/>
           </a:xfrm>
           <a:prstGeom prst="rect">
             <a:avLst/>
@@ -4866,7 +4895,7 @@
         <p:spPr>
           <a:xfrm>
             <a:off x="4517280" y="2309040"/>
-            <a:ext cx="639360" cy="639360"/>
+            <a:ext cx="639720" cy="639720"/>
           </a:xfrm>
           <a:prstGeom prst="roundRect">
             <a:avLst>
@@ -4903,7 +4932,7 @@
         <p:spPr>
           <a:xfrm>
             <a:off x="4681800" y="2473560"/>
-            <a:ext cx="310320" cy="310320"/>
+            <a:ext cx="310680" cy="310680"/>
           </a:xfrm>
           <a:prstGeom prst="rect">
             <a:avLst/>
@@ -4922,7 +4951,7 @@
         <p:spPr>
           <a:xfrm>
             <a:off x="4517280" y="3223440"/>
-            <a:ext cx="3336840" cy="891000"/>
+            <a:ext cx="3337200" cy="891360"/>
           </a:xfrm>
           <a:prstGeom prst="rect">
             <a:avLst/>
@@ -4977,7 +5006,7 @@
         <p:spPr>
           <a:xfrm>
             <a:off x="4517280" y="4114800"/>
-            <a:ext cx="3153960" cy="2193840"/>
+            <a:ext cx="3154320" cy="2194200"/>
           </a:xfrm>
           <a:prstGeom prst="rect">
             <a:avLst/>
@@ -5032,7 +5061,7 @@
         <p:spPr>
           <a:xfrm>
             <a:off x="8394120" y="2309040"/>
-            <a:ext cx="639360" cy="639360"/>
+            <a:ext cx="639720" cy="639720"/>
           </a:xfrm>
           <a:prstGeom prst="roundRect">
             <a:avLst>
@@ -5069,7 +5098,7 @@
         <p:spPr>
           <a:xfrm>
             <a:off x="8558640" y="2473560"/>
-            <a:ext cx="310320" cy="310320"/>
+            <a:ext cx="310680" cy="310680"/>
           </a:xfrm>
           <a:prstGeom prst="rect">
             <a:avLst/>
@@ -5088,7 +5117,7 @@
         <p:spPr>
           <a:xfrm>
             <a:off x="8394120" y="3223440"/>
-            <a:ext cx="3336840" cy="891000"/>
+            <a:ext cx="3337200" cy="891360"/>
           </a:xfrm>
           <a:prstGeom prst="rect">
             <a:avLst/>
@@ -5146,7 +5175,7 @@
         <p:spPr>
           <a:xfrm>
             <a:off x="8394120" y="4114800"/>
-            <a:ext cx="3153960" cy="2193840"/>
+            <a:ext cx="3154320" cy="2194200"/>
           </a:xfrm>
           <a:prstGeom prst="rect">
             <a:avLst/>
@@ -5242,7 +5271,7 @@
         <p:spPr>
           <a:xfrm>
             <a:off x="11228760" y="5897880"/>
-            <a:ext cx="502200" cy="502200"/>
+            <a:ext cx="502560" cy="502560"/>
           </a:xfrm>
           <a:prstGeom prst="rect">
             <a:avLst/>
@@ -5261,7 +5290,7 @@
         <p:spPr>
           <a:xfrm>
             <a:off x="11228760" y="5897880"/>
-            <a:ext cx="502200" cy="502200"/>
+            <a:ext cx="502560" cy="502560"/>
           </a:xfrm>
           <a:prstGeom prst="rect">
             <a:avLst/>
@@ -5316,7 +5345,7 @@
         <p:spPr>
           <a:xfrm>
             <a:off x="640080" y="1607760"/>
-            <a:ext cx="3519720" cy="3976920"/>
+            <a:ext cx="3520080" cy="3977280"/>
           </a:xfrm>
           <a:prstGeom prst="roundRect">
             <a:avLst>
@@ -5349,7 +5378,7 @@
         <p:spPr>
           <a:xfrm>
             <a:off x="822960" y="1790640"/>
-            <a:ext cx="3153960" cy="1553760"/>
+            <a:ext cx="3154320" cy="1554120"/>
           </a:xfrm>
           <a:prstGeom prst="roundRect">
             <a:avLst>
@@ -5391,7 +5420,6 @@
                   <a:srgbClr val="ffffff"/>
                 </a:solidFill>
                 <a:latin typeface="Calibri"/>
-                <a:ea typeface="DejaVu Sans"/>
               </a:rPr>
               <a:t>PIC</a:t>
             </a:r>
@@ -5410,7 +5438,7 @@
         <p:spPr>
           <a:xfrm>
             <a:off x="822960" y="3429000"/>
-            <a:ext cx="3153960" cy="752400"/>
+            <a:ext cx="3154320" cy="752760"/>
           </a:xfrm>
           <a:prstGeom prst="rect">
             <a:avLst/>
@@ -5485,7 +5513,7 @@
         <p:spPr>
           <a:xfrm>
             <a:off x="822960" y="4293000"/>
-            <a:ext cx="3153960" cy="1094760"/>
+            <a:ext cx="3154320" cy="1095120"/>
           </a:xfrm>
           <a:prstGeom prst="rect">
             <a:avLst/>
@@ -5540,7 +5568,7 @@
         <p:spPr>
           <a:xfrm>
             <a:off x="4434840" y="1607760"/>
-            <a:ext cx="3519720" cy="3976920"/>
+            <a:ext cx="3520080" cy="3977280"/>
           </a:xfrm>
           <a:prstGeom prst="roundRect">
             <a:avLst>
@@ -5573,7 +5601,7 @@
         <p:spPr>
           <a:xfrm>
             <a:off x="4617720" y="1790640"/>
-            <a:ext cx="3153960" cy="1553760"/>
+            <a:ext cx="3154320" cy="1554120"/>
           </a:xfrm>
           <a:prstGeom prst="roundRect">
             <a:avLst>
@@ -5615,7 +5643,6 @@
                   <a:srgbClr val="ffffff"/>
                 </a:solidFill>
                 <a:latin typeface="Calibri"/>
-                <a:ea typeface="DejaVu Sans"/>
               </a:rPr>
               <a:t>PIC</a:t>
             </a:r>
@@ -5634,7 +5661,7 @@
         <p:spPr>
           <a:xfrm>
             <a:off x="4617720" y="3429000"/>
-            <a:ext cx="3153960" cy="752400"/>
+            <a:ext cx="3154320" cy="752760"/>
           </a:xfrm>
           <a:prstGeom prst="rect">
             <a:avLst/>
@@ -5689,7 +5716,7 @@
         <p:spPr>
           <a:xfrm>
             <a:off x="4617720" y="4293000"/>
-            <a:ext cx="3153960" cy="1094760"/>
+            <a:ext cx="3154320" cy="1095120"/>
           </a:xfrm>
           <a:prstGeom prst="rect">
             <a:avLst/>
@@ -5744,7 +5771,7 @@
         <p:spPr>
           <a:xfrm>
             <a:off x="8229600" y="1607760"/>
-            <a:ext cx="3519720" cy="3976920"/>
+            <a:ext cx="3520080" cy="3977280"/>
           </a:xfrm>
           <a:prstGeom prst="roundRect">
             <a:avLst>
@@ -5777,7 +5804,7 @@
         <p:spPr>
           <a:xfrm>
             <a:off x="8412480" y="1790640"/>
-            <a:ext cx="3153960" cy="1553760"/>
+            <a:ext cx="3154320" cy="1554120"/>
           </a:xfrm>
           <a:prstGeom prst="roundRect">
             <a:avLst>
@@ -5819,7 +5846,6 @@
                   <a:srgbClr val="ffffff"/>
                 </a:solidFill>
                 <a:latin typeface="Calibri"/>
-                <a:ea typeface="DejaVu Sans"/>
               </a:rPr>
               <a:t>PIC</a:t>
             </a:r>
@@ -5838,7 +5864,7 @@
         <p:spPr>
           <a:xfrm>
             <a:off x="8412480" y="3429000"/>
-            <a:ext cx="3153960" cy="752400"/>
+            <a:ext cx="3154320" cy="752760"/>
           </a:xfrm>
           <a:prstGeom prst="rect">
             <a:avLst/>
@@ -5893,7 +5919,7 @@
         <p:spPr>
           <a:xfrm>
             <a:off x="8412480" y="4293000"/>
-            <a:ext cx="3153960" cy="1094760"/>
+            <a:ext cx="3154320" cy="1095120"/>
           </a:xfrm>
           <a:prstGeom prst="rect">
             <a:avLst/>
@@ -5948,7 +5974,7 @@
         <p:spPr>
           <a:xfrm>
             <a:off x="640080" y="365760"/>
-            <a:ext cx="10908000" cy="1044360"/>
+            <a:ext cx="10908360" cy="1044720"/>
           </a:xfrm>
           <a:prstGeom prst="rect">
             <a:avLst/>
@@ -6044,7 +6070,7 @@
         <p:spPr>
           <a:xfrm>
             <a:off x="0" y="0"/>
-            <a:ext cx="12188160" cy="6857280"/>
+            <a:ext cx="12188520" cy="6857640"/>
           </a:xfrm>
           <a:prstGeom prst="rect">
             <a:avLst/>
@@ -6063,7 +6089,7 @@
         <p:spPr>
           <a:xfrm>
             <a:off x="7589520" y="0"/>
-            <a:ext cx="4598640" cy="6857280"/>
+            <a:ext cx="4599000" cy="6857640"/>
           </a:xfrm>
           <a:prstGeom prst="rect">
             <a:avLst/>
@@ -6103,7 +6129,6 @@
                   <a:srgbClr val="ffffff"/>
                 </a:solidFill>
                 <a:latin typeface="Calibri"/>
-                <a:ea typeface="DejaVu Sans"/>
               </a:rPr>
               <a:t>PIC</a:t>
             </a:r>
@@ -6122,7 +6147,7 @@
         <p:spPr>
           <a:xfrm>
             <a:off x="640080" y="315720"/>
-            <a:ext cx="6609240" cy="1958760"/>
+            <a:ext cx="6609600" cy="1959120"/>
           </a:xfrm>
           <a:prstGeom prst="rect">
             <a:avLst/>
@@ -6177,7 +6202,7 @@
         <p:spPr>
           <a:xfrm>
             <a:off x="640080" y="2590920"/>
-            <a:ext cx="6609240" cy="508680"/>
+            <a:ext cx="6609600" cy="509040"/>
           </a:xfrm>
           <a:prstGeom prst="rect">
             <a:avLst/>
@@ -6232,7 +6257,7 @@
         <p:spPr>
           <a:xfrm>
             <a:off x="640080" y="3189600"/>
-            <a:ext cx="6609240" cy="630720"/>
+            <a:ext cx="6609600" cy="631080"/>
           </a:xfrm>
           <a:prstGeom prst="rect">
             <a:avLst/>
@@ -6287,7 +6312,7 @@
         <p:spPr>
           <a:xfrm>
             <a:off x="640080" y="4192920"/>
-            <a:ext cx="3134520" cy="495720"/>
+            <a:ext cx="3134880" cy="496080"/>
           </a:xfrm>
           <a:prstGeom prst="rect">
             <a:avLst/>
@@ -6318,7 +6343,7 @@
               </a:tabLst>
             </a:pPr>
             <a:r>
-              <a:rPr b="1" lang="en-US" sz="1200" spc="114" strike="noStrike">
+              <a:rPr b="1" lang="en-US" sz="1200" spc="117" strike="noStrike">
                 <a:solidFill>
                   <a:srgbClr val="ff6a3d"/>
                 </a:solidFill>
@@ -6342,7 +6367,7 @@
         <p:spPr>
           <a:xfrm>
             <a:off x="640080" y="4787280"/>
-            <a:ext cx="3134520" cy="1109880"/>
+            <a:ext cx="3134880" cy="1110240"/>
           </a:xfrm>
           <a:prstGeom prst="rect">
             <a:avLst/>
@@ -6397,7 +6422,7 @@
         <p:spPr>
           <a:xfrm>
             <a:off x="4114800" y="4212720"/>
-            <a:ext cx="3134520" cy="457560"/>
+            <a:ext cx="3134880" cy="457920"/>
           </a:xfrm>
           <a:prstGeom prst="rect">
             <a:avLst/>
@@ -6428,7 +6453,7 @@
               </a:tabLst>
             </a:pPr>
             <a:r>
-              <a:rPr b="1" lang="en-US" sz="1200" spc="114" strike="noStrike">
+              <a:rPr b="1" lang="en-US" sz="1200" spc="117" strike="noStrike">
                 <a:solidFill>
                   <a:srgbClr val="ff6a3d"/>
                 </a:solidFill>
@@ -6452,7 +6477,7 @@
         <p:spPr>
           <a:xfrm>
             <a:off x="4114800" y="4787280"/>
-            <a:ext cx="3134520" cy="1109880"/>
+            <a:ext cx="3134880" cy="1110240"/>
           </a:xfrm>
           <a:prstGeom prst="rect">
             <a:avLst/>
@@ -6511,7 +6536,7 @@
         <p:spPr>
           <a:xfrm>
             <a:off x="11228760" y="5897880"/>
-            <a:ext cx="502200" cy="502200"/>
+            <a:ext cx="502560" cy="502560"/>
           </a:xfrm>
           <a:prstGeom prst="rect">
             <a:avLst/>
@@ -6530,7 +6555,7 @@
         <p:spPr>
           <a:xfrm>
             <a:off x="11228760" y="5897880"/>
-            <a:ext cx="502200" cy="502200"/>
+            <a:ext cx="502560" cy="502560"/>
           </a:xfrm>
           <a:prstGeom prst="rect">
             <a:avLst/>
@@ -6626,7 +6651,7 @@
         <p:spPr>
           <a:xfrm>
             <a:off x="11228760" y="5897880"/>
-            <a:ext cx="502200" cy="502200"/>
+            <a:ext cx="502560" cy="502560"/>
           </a:xfrm>
           <a:prstGeom prst="rect">
             <a:avLst/>
@@ -6645,7 +6670,7 @@
         <p:spPr>
           <a:xfrm>
             <a:off x="11228760" y="5897880"/>
-            <a:ext cx="502200" cy="502200"/>
+            <a:ext cx="502560" cy="502560"/>
           </a:xfrm>
           <a:prstGeom prst="rect">
             <a:avLst/>
@@ -6700,7 +6725,7 @@
         <p:spPr>
           <a:xfrm>
             <a:off x="640080" y="2460240"/>
-            <a:ext cx="3153960" cy="730800"/>
+            <a:ext cx="3154320" cy="731160"/>
           </a:xfrm>
           <a:prstGeom prst="rect">
             <a:avLst/>
@@ -6755,7 +6780,7 @@
         <p:spPr>
           <a:xfrm>
             <a:off x="640080" y="3385440"/>
-            <a:ext cx="3153960" cy="1632240"/>
+            <a:ext cx="3154320" cy="1632600"/>
           </a:xfrm>
           <a:prstGeom prst="rect">
             <a:avLst/>
@@ -6838,7 +6863,7 @@
         <p:spPr>
           <a:xfrm>
             <a:off x="4517280" y="2460240"/>
-            <a:ext cx="3153960" cy="730800"/>
+            <a:ext cx="3154320" cy="731160"/>
           </a:xfrm>
           <a:prstGeom prst="rect">
             <a:avLst/>
@@ -6893,7 +6918,7 @@
         <p:spPr>
           <a:xfrm>
             <a:off x="4517280" y="3385440"/>
-            <a:ext cx="3153960" cy="1632240"/>
+            <a:ext cx="3154320" cy="1632600"/>
           </a:xfrm>
           <a:prstGeom prst="rect">
             <a:avLst/>
@@ -6976,7 +7001,7 @@
         <p:spPr>
           <a:xfrm>
             <a:off x="8394120" y="2460240"/>
-            <a:ext cx="3153960" cy="730800"/>
+            <a:ext cx="3154320" cy="731160"/>
           </a:xfrm>
           <a:prstGeom prst="rect">
             <a:avLst/>
@@ -7031,7 +7056,7 @@
         <p:spPr>
           <a:xfrm>
             <a:off x="8394120" y="3385440"/>
-            <a:ext cx="3153960" cy="1632240"/>
+            <a:ext cx="3154320" cy="1632600"/>
           </a:xfrm>
           <a:prstGeom prst="rect">
             <a:avLst/>
@@ -7086,7 +7111,7 @@
         <p:spPr>
           <a:xfrm>
             <a:off x="640080" y="365760"/>
-            <a:ext cx="10908000" cy="1044360"/>
+            <a:ext cx="10908360" cy="1044720"/>
           </a:xfrm>
           <a:prstGeom prst="rect">
             <a:avLst/>
@@ -7171,68 +7196,14 @@
       </p:grpSpPr>
       <p:sp>
         <p:nvSpPr>
-          <p:cNvPr id="110" name="Затемнение"/>
+          <p:cNvPr id="110" name="Чип_1"/>
           <p:cNvSpPr/>
           <p:nvPr/>
         </p:nvSpPr>
         <p:spPr>
           <a:xfrm>
-            <a:off x="0" y="1328040"/>
-            <a:ext cx="12188160" cy="5529240"/>
-          </a:xfrm>
-          <a:prstGeom prst="rect">
-            <a:avLst/>
-          </a:prstGeom>
-          <a:solidFill>
-            <a:srgbClr val="d9d9d9"/>
-          </a:solidFill>
-          <a:ln w="0">
-            <a:noFill/>
-          </a:ln>
-        </p:spPr>
-        <p:style>
-          <a:lnRef idx="0"/>
-          <a:fillRef idx="0"/>
-          <a:effectRef idx="0"/>
-          <a:fontRef idx="minor"/>
-        </p:style>
-        <p:txBody>
-          <a:bodyPr lIns="90000" rIns="90000" tIns="45000" bIns="45000" anchor="ctr">
-            <a:noAutofit/>
-          </a:bodyPr>
-          <a:p>
-            <a:pPr algn="ctr">
-              <a:lnSpc>
-                <a:spcPct val="100000"/>
-              </a:lnSpc>
-              <a:buNone/>
-            </a:pPr>
-            <a:r>
-              <a:rPr b="0" lang="en-US" sz="1800" spc="-1" strike="noStrike">
-                <a:solidFill>
-                  <a:srgbClr val="ffffff"/>
-                </a:solidFill>
-                <a:latin typeface="Calibri"/>
-                <a:ea typeface="DejaVu Sans"/>
-              </a:rPr>
-              <a:t>PIC</a:t>
-            </a:r>
-            <a:endParaRPr b="0" lang="en-US" sz="1800" spc="-1" strike="noStrike">
-              <a:latin typeface="Arial"/>
-            </a:endParaRPr>
-          </a:p>
-        </p:txBody>
-      </p:sp>
-      <p:sp>
-        <p:nvSpPr>
-          <p:cNvPr id="111" name="Чип_1"/>
-          <p:cNvSpPr/>
-          <p:nvPr/>
-        </p:nvSpPr>
-        <p:spPr>
-          <a:xfrm>
-            <a:off x="474480" y="5290560"/>
-            <a:ext cx="4673520" cy="1255320"/>
+            <a:off x="639360" y="5290560"/>
+            <a:ext cx="5315040" cy="1255680"/>
           </a:xfrm>
           <a:prstGeom prst="roundRect">
             <a:avLst>
@@ -7260,14 +7231,14 @@
       </p:sp>
       <p:sp>
         <p:nvSpPr>
-          <p:cNvPr id="112" name="SUBTITLE 2"/>
+          <p:cNvPr id="111" name="SUBTITLE 2"/>
           <p:cNvSpPr/>
           <p:nvPr/>
         </p:nvSpPr>
         <p:spPr>
           <a:xfrm>
-            <a:off x="639360" y="5413320"/>
-            <a:ext cx="4345560" cy="465120"/>
+            <a:off x="803880" y="5413320"/>
+            <a:ext cx="4345920" cy="465480"/>
           </a:xfrm>
           <a:prstGeom prst="rect">
             <a:avLst/>
@@ -7298,7 +7269,7 @@
               </a:tabLst>
             </a:pPr>
             <a:r>
-              <a:rPr b="1" lang="en-US" sz="1200" spc="94" strike="noStrike">
+              <a:rPr b="1" lang="en-US" sz="1200" spc="97" strike="noStrike">
                 <a:solidFill>
                   <a:srgbClr val="ff6a3d"/>
                 </a:solidFill>
@@ -7315,14 +7286,14 @@
       </p:sp>
       <p:sp>
         <p:nvSpPr>
-          <p:cNvPr id="113" name="TEXT 2"/>
+          <p:cNvPr id="112" name="TEXT 2"/>
           <p:cNvSpPr/>
           <p:nvPr/>
         </p:nvSpPr>
         <p:spPr>
           <a:xfrm>
-            <a:off x="639360" y="5952240"/>
-            <a:ext cx="4345560" cy="502200"/>
+            <a:off x="803880" y="5952240"/>
+            <a:ext cx="4345920" cy="502560"/>
           </a:xfrm>
           <a:prstGeom prst="rect">
             <a:avLst/>
@@ -7368,94 +7339,16 @@
           </a:p>
         </p:txBody>
       </p:sp>
-      <p:pic>
-        <p:nvPicPr>
-          <p:cNvPr id="114" name="Кнопка_Навигация_Фон" descr="/home/claude/vistas/assets/grad_circle.png"/>
-          <p:cNvPicPr/>
-          <p:nvPr/>
-        </p:nvPicPr>
-        <p:blipFill>
-          <a:blip r:embed="rId1"/>
-          <a:stretch/>
-        </p:blipFill>
-        <p:spPr>
-          <a:xfrm>
-            <a:off x="11228760" y="5897880"/>
-            <a:ext cx="502200" cy="502200"/>
-          </a:xfrm>
-          <a:prstGeom prst="rect">
-            <a:avLst/>
-          </a:prstGeom>
-          <a:ln w="0">
-            <a:noFill/>
-          </a:ln>
-        </p:spPr>
-      </p:pic>
-      <p:sp>
-        <p:nvSpPr>
-          <p:cNvPr id="115" name="Кнопка_Навигация_Стрелка"/>
+      <p:sp>
+        <p:nvSpPr>
+          <p:cNvPr id="113" name="Чип_1"/>
           <p:cNvSpPr/>
           <p:nvPr/>
         </p:nvSpPr>
         <p:spPr>
           <a:xfrm>
-            <a:off x="11228760" y="5897880"/>
-            <a:ext cx="502200" cy="502200"/>
-          </a:xfrm>
-          <a:prstGeom prst="rect">
-            <a:avLst/>
-          </a:prstGeom>
-          <a:noFill/>
-          <a:ln w="0">
-            <a:noFill/>
-          </a:ln>
-        </p:spPr>
-        <p:style>
-          <a:lnRef idx="0"/>
-          <a:fillRef idx="0"/>
-          <a:effectRef idx="0"/>
-          <a:fontRef idx="minor"/>
-        </p:style>
-        <p:txBody>
-          <a:bodyPr lIns="0" rIns="0" tIns="0" bIns="0" anchor="ctr">
-            <a:noAutofit/>
-          </a:bodyPr>
-          <a:p>
-            <a:pPr algn="ctr">
-              <a:lnSpc>
-                <a:spcPct val="100000"/>
-              </a:lnSpc>
-              <a:buNone/>
-              <a:tabLst>
-                <a:tab algn="l" pos="0"/>
-              </a:tabLst>
-            </a:pPr>
-            <a:r>
-              <a:rPr b="1" lang="en-US" sz="2000" spc="-1" strike="noStrike">
-                <a:solidFill>
-                  <a:srgbClr val="ffffff"/>
-                </a:solidFill>
-                <a:latin typeface="Arial"/>
-                <a:ea typeface="Arial"/>
-              </a:rPr>
-              <a:t>→</a:t>
-            </a:r>
-            <a:endParaRPr b="0" lang="en-US" sz="2000" spc="-1" strike="noStrike">
-              <a:latin typeface="Arial"/>
-            </a:endParaRPr>
-          </a:p>
-        </p:txBody>
-      </p:sp>
-      <p:sp>
-        <p:nvSpPr>
-          <p:cNvPr id="116" name="Чип_1"/>
-          <p:cNvSpPr/>
-          <p:nvPr/>
-        </p:nvSpPr>
-        <p:spPr>
-          <a:xfrm>
-            <a:off x="5677560" y="5290560"/>
-            <a:ext cx="4673520" cy="1255320"/>
+            <a:off x="6234480" y="5290560"/>
+            <a:ext cx="5313240" cy="1255680"/>
           </a:xfrm>
           <a:prstGeom prst="roundRect">
             <a:avLst>
@@ -7483,14 +7376,14 @@
       </p:sp>
       <p:sp>
         <p:nvSpPr>
-          <p:cNvPr id="117" name="SUBTITLE 2"/>
+          <p:cNvPr id="114" name="SUBTITLE 2"/>
           <p:cNvSpPr/>
           <p:nvPr/>
         </p:nvSpPr>
         <p:spPr>
           <a:xfrm>
-            <a:off x="5842080" y="5413320"/>
-            <a:ext cx="4345560" cy="465120"/>
+            <a:off x="6399000" y="5413320"/>
+            <a:ext cx="4345920" cy="465480"/>
           </a:xfrm>
           <a:prstGeom prst="rect">
             <a:avLst/>
@@ -7521,7 +7414,7 @@
               </a:tabLst>
             </a:pPr>
             <a:r>
-              <a:rPr b="1" lang="en-US" sz="1200" spc="94" strike="noStrike">
+              <a:rPr b="1" lang="en-US" sz="1200" spc="97" strike="noStrike">
                 <a:solidFill>
                   <a:srgbClr val="ff6a3d"/>
                 </a:solidFill>
@@ -7531,7 +7424,7 @@
               <a:t>SUBTITLE</a:t>
             </a:r>
             <a:r>
-              <a:rPr b="1" lang="ru-RU" sz="1200" spc="94" strike="noStrike">
+              <a:rPr b="1" lang="ru-RU" sz="1200" spc="97" strike="noStrike">
                 <a:solidFill>
                   <a:srgbClr val="ff6a3d"/>
                 </a:solidFill>
@@ -7548,14 +7441,14 @@
       </p:sp>
       <p:sp>
         <p:nvSpPr>
-          <p:cNvPr id="118" name="TEXT 2"/>
+          <p:cNvPr id="115" name="TEXT 2"/>
           <p:cNvSpPr/>
           <p:nvPr/>
         </p:nvSpPr>
         <p:spPr>
           <a:xfrm>
-            <a:off x="5842080" y="5952240"/>
-            <a:ext cx="4345560" cy="502200"/>
+            <a:off x="6399000" y="5952240"/>
+            <a:ext cx="4345920" cy="502560"/>
           </a:xfrm>
           <a:prstGeom prst="rect">
             <a:avLst/>
@@ -7613,14 +7506,14 @@
       </p:sp>
       <p:sp>
         <p:nvSpPr>
-          <p:cNvPr id="119" name="Чип_1"/>
+          <p:cNvPr id="116" name="Чип_1"/>
           <p:cNvSpPr/>
           <p:nvPr/>
         </p:nvSpPr>
         <p:spPr>
           <a:xfrm>
-            <a:off x="474480" y="4143240"/>
-            <a:ext cx="9876600" cy="976680"/>
+            <a:off x="639360" y="4143240"/>
+            <a:ext cx="10908360" cy="977040"/>
           </a:xfrm>
           <a:prstGeom prst="roundRect">
             <a:avLst>
@@ -7648,14 +7541,14 @@
       </p:sp>
       <p:sp>
         <p:nvSpPr>
-          <p:cNvPr id="120" name="SUBTITLE 2"/>
+          <p:cNvPr id="117" name="SUBTITLE 2"/>
           <p:cNvSpPr/>
           <p:nvPr/>
         </p:nvSpPr>
         <p:spPr>
           <a:xfrm>
-            <a:off x="639360" y="4143240"/>
-            <a:ext cx="9548640" cy="309240"/>
+            <a:off x="803880" y="4143240"/>
+            <a:ext cx="9549000" cy="309600"/>
           </a:xfrm>
           <a:prstGeom prst="rect">
             <a:avLst/>
@@ -7686,7 +7579,7 @@
               </a:tabLst>
             </a:pPr>
             <a:r>
-              <a:rPr b="1" lang="en-US" sz="1200" spc="94" strike="noStrike">
+              <a:rPr b="1" lang="en-US" sz="1200" spc="97" strike="noStrike">
                 <a:solidFill>
                   <a:srgbClr val="ff6a3d"/>
                 </a:solidFill>
@@ -7696,7 +7589,7 @@
               <a:t>SUBTITLE</a:t>
             </a:r>
             <a:r>
-              <a:rPr b="1" lang="ru-RU" sz="1200" spc="94" strike="noStrike">
+              <a:rPr b="1" lang="ru-RU" sz="1200" spc="97" strike="noStrike">
                 <a:solidFill>
                   <a:srgbClr val="ff6a3d"/>
                 </a:solidFill>
@@ -7713,14 +7606,14 @@
       </p:sp>
       <p:sp>
         <p:nvSpPr>
-          <p:cNvPr id="121" name="TEXT 2"/>
+          <p:cNvPr id="118" name="TEXT 2"/>
           <p:cNvSpPr/>
           <p:nvPr/>
         </p:nvSpPr>
         <p:spPr>
           <a:xfrm>
-            <a:off x="639360" y="4526280"/>
-            <a:ext cx="9548640" cy="502200"/>
+            <a:off x="803880" y="4526280"/>
+            <a:ext cx="9549000" cy="502560"/>
           </a:xfrm>
           <a:prstGeom prst="rect">
             <a:avLst/>
@@ -7778,14 +7671,14 @@
       </p:sp>
       <p:sp>
         <p:nvSpPr>
-          <p:cNvPr id="122" name="TITLE"/>
+          <p:cNvPr id="119" name="TITLE"/>
           <p:cNvSpPr/>
           <p:nvPr/>
         </p:nvSpPr>
         <p:spPr>
           <a:xfrm>
             <a:off x="640080" y="365760"/>
-            <a:ext cx="10908000" cy="1044360"/>
+            <a:ext cx="10908360" cy="1044720"/>
           </a:xfrm>
           <a:prstGeom prst="rect">
             <a:avLst/>
@@ -7826,6 +7719,66 @@
               <a:t>TITLE</a:t>
             </a:r>
             <a:endParaRPr b="0" lang="en-US" sz="3200" spc="-1" strike="noStrike">
+              <a:latin typeface="Arial"/>
+            </a:endParaRPr>
+          </a:p>
+        </p:txBody>
+      </p:sp>
+      <p:sp>
+        <p:nvSpPr>
+          <p:cNvPr id="120" name="PIC 1"/>
+          <p:cNvSpPr/>
+          <p:nvPr/>
+        </p:nvSpPr>
+        <p:spPr>
+          <a:xfrm>
+            <a:off x="638280" y="1410840"/>
+            <a:ext cx="10908360" cy="2447640"/>
+          </a:xfrm>
+          <a:prstGeom prst="roundRect">
+            <a:avLst>
+              <a:gd name="adj" fmla="val 4706"/>
+            </a:avLst>
+          </a:prstGeom>
+          <a:solidFill>
+            <a:schemeClr val="bg1">
+              <a:lumMod val="85000"/>
+            </a:schemeClr>
+          </a:solidFill>
+          <a:ln w="9525">
+            <a:solidFill>
+              <a:srgbClr val="6e6e6e"/>
+            </a:solidFill>
+            <a:round/>
+          </a:ln>
+        </p:spPr>
+        <p:style>
+          <a:lnRef idx="0"/>
+          <a:fillRef idx="0"/>
+          <a:effectRef idx="0"/>
+          <a:fontRef idx="minor"/>
+        </p:style>
+        <p:txBody>
+          <a:bodyPr lIns="90000" rIns="90000" tIns="45000" bIns="45000" anchor="ctr">
+            <a:noAutofit/>
+          </a:bodyPr>
+          <a:p>
+            <a:pPr algn="ctr">
+              <a:lnSpc>
+                <a:spcPct val="100000"/>
+              </a:lnSpc>
+              <a:buNone/>
+            </a:pPr>
+            <a:r>
+              <a:rPr b="0" lang="en-US" sz="1800" spc="-1" strike="noStrike">
+                <a:solidFill>
+                  <a:srgbClr val="ffffff"/>
+                </a:solidFill>
+                <a:latin typeface="Calibri"/>
+              </a:rPr>
+              <a:t>PIC</a:t>
+            </a:r>
+            <a:endParaRPr b="0" lang="en-US" sz="1800" spc="-1" strike="noStrike">
               <a:latin typeface="Arial"/>
             </a:endParaRPr>
           </a:p>
@@ -7870,14 +7823,14 @@
       </p:grpSpPr>
       <p:sp>
         <p:nvSpPr>
-          <p:cNvPr id="123" name="Блок_3"/>
+          <p:cNvPr id="121" name="Блок_3"/>
           <p:cNvSpPr/>
           <p:nvPr/>
         </p:nvSpPr>
         <p:spPr>
           <a:xfrm>
             <a:off x="8229600" y="2377440"/>
-            <a:ext cx="3519720" cy="3565440"/>
+            <a:ext cx="3520080" cy="3565800"/>
           </a:xfrm>
           <a:prstGeom prst="roundRect">
             <a:avLst>
@@ -7903,14 +7856,14 @@
       </p:sp>
       <p:sp>
         <p:nvSpPr>
-          <p:cNvPr id="124" name="Блок_1"/>
+          <p:cNvPr id="122" name="Блок_1"/>
           <p:cNvSpPr/>
           <p:nvPr/>
         </p:nvSpPr>
         <p:spPr>
           <a:xfrm>
             <a:off x="640080" y="2377440"/>
-            <a:ext cx="3519720" cy="3565440"/>
+            <a:ext cx="3520080" cy="3565800"/>
           </a:xfrm>
           <a:prstGeom prst="roundRect">
             <a:avLst>
@@ -7936,7 +7889,7 @@
       </p:sp>
       <p:pic>
         <p:nvPicPr>
-          <p:cNvPr id="125" name="Кнопка_Навигация_Фон" descr="/home/claude/vistas/assets/grad_circle.png"/>
+          <p:cNvPr id="123" name="Кнопка_Навигация_Фон" descr="/home/claude/vistas/assets/grad_circle.png"/>
           <p:cNvPicPr/>
           <p:nvPr/>
         </p:nvPicPr>
@@ -7947,7 +7900,7 @@
         <p:spPr>
           <a:xfrm>
             <a:off x="11228760" y="5897880"/>
-            <a:ext cx="502200" cy="502200"/>
+            <a:ext cx="502560" cy="502560"/>
           </a:xfrm>
           <a:prstGeom prst="rect">
             <a:avLst/>
@@ -7959,14 +7912,14 @@
       </p:pic>
       <p:sp>
         <p:nvSpPr>
-          <p:cNvPr id="126" name="SUBTITLE 1"/>
+          <p:cNvPr id="124" name="SUBTITLE 1"/>
           <p:cNvSpPr/>
           <p:nvPr/>
         </p:nvSpPr>
         <p:spPr>
           <a:xfrm>
             <a:off x="914400" y="2491920"/>
-            <a:ext cx="2971080" cy="685080"/>
+            <a:ext cx="2971440" cy="685440"/>
           </a:xfrm>
           <a:prstGeom prst="rect">
             <a:avLst/>
@@ -8014,14 +7967,14 @@
       </p:sp>
       <p:sp>
         <p:nvSpPr>
-          <p:cNvPr id="127" name="TEXT 1"/>
+          <p:cNvPr id="125" name="TEXT 1"/>
           <p:cNvSpPr/>
           <p:nvPr/>
         </p:nvSpPr>
         <p:spPr>
           <a:xfrm>
             <a:off x="914400" y="3314880"/>
-            <a:ext cx="2971080" cy="2468160"/>
+            <a:ext cx="2971440" cy="2468520"/>
           </a:xfrm>
           <a:prstGeom prst="rect">
             <a:avLst/>
@@ -8069,14 +8022,14 @@
       </p:sp>
       <p:sp>
         <p:nvSpPr>
-          <p:cNvPr id="128" name="Блок_2"/>
+          <p:cNvPr id="126" name="Блок_2"/>
           <p:cNvSpPr/>
           <p:nvPr/>
         </p:nvSpPr>
         <p:spPr>
           <a:xfrm>
             <a:off x="4434840" y="2377440"/>
-            <a:ext cx="3519720" cy="3565440"/>
+            <a:ext cx="3520080" cy="3565800"/>
           </a:xfrm>
           <a:prstGeom prst="roundRect">
             <a:avLst>
@@ -8102,14 +8055,14 @@
       </p:sp>
       <p:sp>
         <p:nvSpPr>
-          <p:cNvPr id="129" name="SUBTITLE 2"/>
+          <p:cNvPr id="127" name="SUBTITLE 2"/>
           <p:cNvSpPr/>
           <p:nvPr/>
         </p:nvSpPr>
         <p:spPr>
           <a:xfrm>
             <a:off x="4709160" y="2491920"/>
-            <a:ext cx="2971080" cy="685080"/>
+            <a:ext cx="2971440" cy="685440"/>
           </a:xfrm>
           <a:prstGeom prst="rect">
             <a:avLst/>
@@ -8157,14 +8110,14 @@
       </p:sp>
       <p:sp>
         <p:nvSpPr>
-          <p:cNvPr id="130" name="TEXT 2"/>
+          <p:cNvPr id="128" name="TEXT 2"/>
           <p:cNvSpPr/>
           <p:nvPr/>
         </p:nvSpPr>
         <p:spPr>
           <a:xfrm>
             <a:off x="4709160" y="3314880"/>
-            <a:ext cx="2971080" cy="2468160"/>
+            <a:ext cx="2971440" cy="2468520"/>
           </a:xfrm>
           <a:prstGeom prst="rect">
             <a:avLst/>
@@ -8212,14 +8165,14 @@
       </p:sp>
       <p:sp>
         <p:nvSpPr>
-          <p:cNvPr id="131" name="SUBTITLE 3"/>
+          <p:cNvPr id="129" name="SUBTITLE 3"/>
           <p:cNvSpPr/>
           <p:nvPr/>
         </p:nvSpPr>
         <p:spPr>
           <a:xfrm>
             <a:off x="8503920" y="2491920"/>
-            <a:ext cx="2971080" cy="685080"/>
+            <a:ext cx="2971440" cy="685440"/>
           </a:xfrm>
           <a:prstGeom prst="rect">
             <a:avLst/>
@@ -8267,14 +8220,14 @@
       </p:sp>
       <p:sp>
         <p:nvSpPr>
-          <p:cNvPr id="132" name="TEXT 3"/>
+          <p:cNvPr id="130" name="TEXT 3"/>
           <p:cNvSpPr/>
           <p:nvPr/>
         </p:nvSpPr>
         <p:spPr>
           <a:xfrm>
             <a:off x="8503920" y="3314880"/>
-            <a:ext cx="2971080" cy="2468160"/>
+            <a:ext cx="2971440" cy="2468520"/>
           </a:xfrm>
           <a:prstGeom prst="rect">
             <a:avLst/>
@@ -8322,14 +8275,14 @@
       </p:sp>
       <p:sp>
         <p:nvSpPr>
-          <p:cNvPr id="133" name="TITLE"/>
+          <p:cNvPr id="131" name="TITLE"/>
           <p:cNvSpPr/>
           <p:nvPr/>
         </p:nvSpPr>
         <p:spPr>
           <a:xfrm>
             <a:off x="640080" y="365760"/>
-            <a:ext cx="10908000" cy="1044360"/>
+            <a:ext cx="10908360" cy="1044720"/>
           </a:xfrm>
           <a:prstGeom prst="rect">
             <a:avLst/>
@@ -8377,14 +8330,14 @@
       </p:sp>
       <p:sp>
         <p:nvSpPr>
-          <p:cNvPr id="134" name="Кнопка_Навигация_Стрелка"/>
+          <p:cNvPr id="132" name="Кнопка_Навигация_Стрелка"/>
           <p:cNvSpPr/>
           <p:nvPr/>
         </p:nvSpPr>
         <p:spPr>
           <a:xfrm>
             <a:off x="11228760" y="5897880"/>
-            <a:ext cx="502200" cy="502200"/>
+            <a:ext cx="502560" cy="502560"/>
           </a:xfrm>
           <a:prstGeom prst="rect">
             <a:avLst/>
@@ -8469,14 +8422,14 @@
       </p:grpSpPr>
       <p:sp>
         <p:nvSpPr>
-          <p:cNvPr id="135" name="Карточка_1"/>
+          <p:cNvPr id="133" name="Карточка_1"/>
           <p:cNvSpPr/>
           <p:nvPr/>
         </p:nvSpPr>
         <p:spPr>
           <a:xfrm>
             <a:off x="640080" y="1458720"/>
-            <a:ext cx="3519720" cy="4114080"/>
+            <a:ext cx="3520080" cy="4114440"/>
           </a:xfrm>
           <a:prstGeom prst="roundRect">
             <a:avLst>
@@ -8502,14 +8455,14 @@
       </p:sp>
       <p:sp>
         <p:nvSpPr>
-          <p:cNvPr id="136" name="PIC 1"/>
+          <p:cNvPr id="134" name="PIC 1"/>
           <p:cNvSpPr/>
           <p:nvPr/>
         </p:nvSpPr>
         <p:spPr>
           <a:xfrm>
             <a:off x="822960" y="1641600"/>
-            <a:ext cx="3153960" cy="1828080"/>
+            <a:ext cx="3154320" cy="1828440"/>
           </a:xfrm>
           <a:prstGeom prst="roundRect">
             <a:avLst>
@@ -8549,7 +8502,6 @@
                   <a:srgbClr val="ffffff"/>
                 </a:solidFill>
                 <a:latin typeface="Calibri"/>
-                <a:ea typeface="DejaVu Sans"/>
               </a:rPr>
               <a:t>PIC</a:t>
             </a:r>
@@ -8561,14 +8513,14 @@
       </p:sp>
       <p:sp>
         <p:nvSpPr>
-          <p:cNvPr id="137" name="SUBTITLE 1"/>
+          <p:cNvPr id="135" name="SUBTITLE 1"/>
           <p:cNvSpPr/>
           <p:nvPr/>
         </p:nvSpPr>
         <p:spPr>
           <a:xfrm>
             <a:off x="822960" y="3568320"/>
-            <a:ext cx="3153960" cy="547920"/>
+            <a:ext cx="3154320" cy="548280"/>
           </a:xfrm>
           <a:prstGeom prst="rect">
             <a:avLst/>
@@ -8616,14 +8568,14 @@
       </p:sp>
       <p:sp>
         <p:nvSpPr>
-          <p:cNvPr id="138" name="TEXT 1"/>
+          <p:cNvPr id="136" name="TEXT 1"/>
           <p:cNvSpPr/>
           <p:nvPr/>
         </p:nvSpPr>
         <p:spPr>
           <a:xfrm>
             <a:off x="822960" y="4184640"/>
-            <a:ext cx="3153960" cy="1170720"/>
+            <a:ext cx="3154320" cy="1171080"/>
           </a:xfrm>
           <a:prstGeom prst="rect">
             <a:avLst/>
@@ -8671,14 +8623,14 @@
       </p:sp>
       <p:sp>
         <p:nvSpPr>
-          <p:cNvPr id="139" name="Карточка_2"/>
+          <p:cNvPr id="137" name="Карточка_2"/>
           <p:cNvSpPr/>
           <p:nvPr/>
         </p:nvSpPr>
         <p:spPr>
           <a:xfrm>
             <a:off x="4434840" y="1458720"/>
-            <a:ext cx="3519720" cy="4114080"/>
+            <a:ext cx="3520080" cy="4114440"/>
           </a:xfrm>
           <a:prstGeom prst="roundRect">
             <a:avLst>
@@ -8704,14 +8656,14 @@
       </p:sp>
       <p:sp>
         <p:nvSpPr>
-          <p:cNvPr id="140" name="PIC 2"/>
+          <p:cNvPr id="138" name="PIC 2"/>
           <p:cNvSpPr/>
           <p:nvPr/>
         </p:nvSpPr>
         <p:spPr>
           <a:xfrm>
             <a:off x="4617720" y="1641600"/>
-            <a:ext cx="3153960" cy="1828080"/>
+            <a:ext cx="3154320" cy="1828440"/>
           </a:xfrm>
           <a:prstGeom prst="roundRect">
             <a:avLst>
@@ -8751,7 +8703,6 @@
                   <a:srgbClr val="ffffff"/>
                 </a:solidFill>
                 <a:latin typeface="Calibri"/>
-                <a:ea typeface="DejaVu Sans"/>
               </a:rPr>
               <a:t>PIC</a:t>
             </a:r>
@@ -8763,14 +8714,14 @@
       </p:sp>
       <p:sp>
         <p:nvSpPr>
-          <p:cNvPr id="141" name="SUBTITLE 2"/>
+          <p:cNvPr id="139" name="SUBTITLE 2"/>
           <p:cNvSpPr/>
           <p:nvPr/>
         </p:nvSpPr>
         <p:spPr>
           <a:xfrm>
             <a:off x="4617720" y="3568320"/>
-            <a:ext cx="3153960" cy="547920"/>
+            <a:ext cx="3154320" cy="548280"/>
           </a:xfrm>
           <a:prstGeom prst="rect">
             <a:avLst/>
@@ -8818,14 +8769,14 @@
       </p:sp>
       <p:sp>
         <p:nvSpPr>
-          <p:cNvPr id="142" name="TEXT 2"/>
+          <p:cNvPr id="140" name="TEXT 2"/>
           <p:cNvSpPr/>
           <p:nvPr/>
         </p:nvSpPr>
         <p:spPr>
           <a:xfrm>
             <a:off x="4617720" y="4184640"/>
-            <a:ext cx="3153960" cy="1170720"/>
+            <a:ext cx="3154320" cy="1171080"/>
           </a:xfrm>
           <a:prstGeom prst="rect">
             <a:avLst/>
@@ -8873,14 +8824,14 @@
       </p:sp>
       <p:sp>
         <p:nvSpPr>
-          <p:cNvPr id="143" name="Карточка_3"/>
+          <p:cNvPr id="141" name="Карточка_3"/>
           <p:cNvSpPr/>
           <p:nvPr/>
         </p:nvSpPr>
         <p:spPr>
           <a:xfrm>
             <a:off x="8229600" y="1458720"/>
-            <a:ext cx="3519720" cy="4114080"/>
+            <a:ext cx="3520080" cy="4114440"/>
           </a:xfrm>
           <a:prstGeom prst="roundRect">
             <a:avLst>
@@ -8906,14 +8857,14 @@
       </p:sp>
       <p:sp>
         <p:nvSpPr>
-          <p:cNvPr id="144" name="PIC 3"/>
+          <p:cNvPr id="142" name="PIC 3"/>
           <p:cNvSpPr/>
           <p:nvPr/>
         </p:nvSpPr>
         <p:spPr>
           <a:xfrm>
             <a:off x="8412480" y="1641600"/>
-            <a:ext cx="3153960" cy="1828080"/>
+            <a:ext cx="3154320" cy="1828440"/>
           </a:xfrm>
           <a:prstGeom prst="roundRect">
             <a:avLst>
@@ -8953,7 +8904,6 @@
                   <a:srgbClr val="ffffff"/>
                 </a:solidFill>
                 <a:latin typeface="Calibri"/>
-                <a:ea typeface="DejaVu Sans"/>
               </a:rPr>
               <a:t>PIC</a:t>
             </a:r>
@@ -8965,14 +8915,14 @@
       </p:sp>
       <p:sp>
         <p:nvSpPr>
-          <p:cNvPr id="145" name="SUBTITLE 3"/>
+          <p:cNvPr id="143" name="SUBTITLE 3"/>
           <p:cNvSpPr/>
           <p:nvPr/>
         </p:nvSpPr>
         <p:spPr>
           <a:xfrm>
             <a:off x="8412480" y="3568320"/>
-            <a:ext cx="3153960" cy="547920"/>
+            <a:ext cx="3154320" cy="548280"/>
           </a:xfrm>
           <a:prstGeom prst="rect">
             <a:avLst/>
@@ -9020,14 +8970,14 @@
       </p:sp>
       <p:sp>
         <p:nvSpPr>
-          <p:cNvPr id="146" name="TEXT 3"/>
+          <p:cNvPr id="144" name="TEXT 3"/>
           <p:cNvSpPr/>
           <p:nvPr/>
         </p:nvSpPr>
         <p:spPr>
           <a:xfrm>
             <a:off x="8412480" y="4184640"/>
-            <a:ext cx="3153960" cy="1170720"/>
+            <a:ext cx="3154320" cy="1171080"/>
           </a:xfrm>
           <a:prstGeom prst="rect">
             <a:avLst/>
@@ -9075,14 +9025,14 @@
       </p:sp>
       <p:sp>
         <p:nvSpPr>
-          <p:cNvPr id="147" name="TITLE"/>
+          <p:cNvPr id="145" name="TITLE"/>
           <p:cNvSpPr/>
           <p:nvPr/>
         </p:nvSpPr>
         <p:spPr>
           <a:xfrm>
             <a:off x="640080" y="365760"/>
-            <a:ext cx="10908000" cy="1044360"/>
+            <a:ext cx="10908360" cy="1044720"/>
           </a:xfrm>
           <a:prstGeom prst="rect">
             <a:avLst/>
@@ -9130,7 +9080,7 @@
       </p:sp>
       <p:pic>
         <p:nvPicPr>
-          <p:cNvPr id="148" name="Кнопка_Навигация_Фон" descr="/home/claude/vistas/assets/grad_circle.png"/>
+          <p:cNvPr id="146" name="Кнопка_Навигация_Фон" descr="/home/claude/vistas/assets/grad_circle.png"/>
           <p:cNvPicPr/>
           <p:nvPr/>
         </p:nvPicPr>
@@ -9141,7 +9091,7 @@
         <p:spPr>
           <a:xfrm>
             <a:off x="11228760" y="5897880"/>
-            <a:ext cx="502200" cy="502200"/>
+            <a:ext cx="502560" cy="502560"/>
           </a:xfrm>
           <a:prstGeom prst="rect">
             <a:avLst/>
@@ -9153,14 +9103,14 @@
       </p:pic>
       <p:sp>
         <p:nvSpPr>
-          <p:cNvPr id="149" name="Кнопка_Навигация_Стрелка"/>
+          <p:cNvPr id="147" name="Кнопка_Навигация_Стрелка"/>
           <p:cNvSpPr/>
           <p:nvPr/>
         </p:nvSpPr>
         <p:spPr>
           <a:xfrm>
             <a:off x="11228760" y="5897880"/>
-            <a:ext cx="502200" cy="502200"/>
+            <a:ext cx="502560" cy="502560"/>
           </a:xfrm>
           <a:prstGeom prst="rect">
             <a:avLst/>

</xml_diff>